<commit_message>
added community card for ralph schuhmacher
</commit_message>
<xml_diff>
--- a/assets-helper/community_event_cards.pptx
+++ b/assets-helper/community_event_cards.pptx
@@ -21,22 +21,23 @@
     <p:sldId id="269" r:id="rId15"/>
     <p:sldId id="270" r:id="rId16"/>
     <p:sldId id="271" r:id="rId17"/>
-    <p:sldId id="272" r:id="rId18"/>
-    <p:sldId id="273" r:id="rId19"/>
-    <p:sldId id="274" r:id="rId20"/>
-    <p:sldId id="275" r:id="rId21"/>
-    <p:sldId id="276" r:id="rId22"/>
-    <p:sldId id="277" r:id="rId23"/>
-    <p:sldId id="278" r:id="rId24"/>
-    <p:sldId id="279" r:id="rId25"/>
-    <p:sldId id="280" r:id="rId26"/>
-    <p:sldId id="282" r:id="rId27"/>
-    <p:sldId id="281" r:id="rId28"/>
-    <p:sldId id="283" r:id="rId29"/>
-    <p:sldId id="284" r:id="rId30"/>
-    <p:sldId id="285" r:id="rId31"/>
-    <p:sldId id="287" r:id="rId32"/>
-    <p:sldId id="286" r:id="rId33"/>
+    <p:sldId id="288" r:id="rId18"/>
+    <p:sldId id="272" r:id="rId19"/>
+    <p:sldId id="273" r:id="rId20"/>
+    <p:sldId id="274" r:id="rId21"/>
+    <p:sldId id="275" r:id="rId22"/>
+    <p:sldId id="276" r:id="rId23"/>
+    <p:sldId id="277" r:id="rId24"/>
+    <p:sldId id="278" r:id="rId25"/>
+    <p:sldId id="279" r:id="rId26"/>
+    <p:sldId id="280" r:id="rId27"/>
+    <p:sldId id="282" r:id="rId28"/>
+    <p:sldId id="281" r:id="rId29"/>
+    <p:sldId id="283" r:id="rId30"/>
+    <p:sldId id="284" r:id="rId31"/>
+    <p:sldId id="285" r:id="rId32"/>
+    <p:sldId id="287" r:id="rId33"/>
+    <p:sldId id="286" r:id="rId34"/>
   </p:sldIdLst>
   <p:sldSz cx="12192000" cy="6858000"/>
   <p:notesSz cx="6858000" cy="9144000"/>
@@ -135,6 +136,56 @@
       </a:defRPr>
     </a:lvl9pPr>
   </p:defaultTextStyle>
+  <p:extLst>
+    <p:ext uri="{521415D9-36F7-43E2-AB2F-B90AF26B5E84}">
+      <p14:sectionLst xmlns:p14="http://schemas.microsoft.com/office/powerpoint/2010/main">
+        <p14:section name="CommunityCard" id="{9C2F9C8D-6774-44E8-9775-06400EFA97A4}">
+          <p14:sldIdLst>
+            <p14:sldId id="256"/>
+            <p14:sldId id="257"/>
+            <p14:sldId id="258"/>
+            <p14:sldId id="259"/>
+            <p14:sldId id="260"/>
+            <p14:sldId id="261"/>
+            <p14:sldId id="262"/>
+            <p14:sldId id="263"/>
+            <p14:sldId id="264"/>
+            <p14:sldId id="265"/>
+            <p14:sldId id="266"/>
+            <p14:sldId id="267"/>
+            <p14:sldId id="268"/>
+            <p14:sldId id="269"/>
+            <p14:sldId id="270"/>
+            <p14:sldId id="271"/>
+            <p14:sldId id="288"/>
+          </p14:sldIdLst>
+        </p14:section>
+        <p14:section name="EventCard" id="{F2C7E526-EFB5-4F4E-8491-24CCFDA23413}">
+          <p14:sldIdLst>
+            <p14:sldId id="272"/>
+            <p14:sldId id="273"/>
+            <p14:sldId id="274"/>
+            <p14:sldId id="275"/>
+            <p14:sldId id="276"/>
+            <p14:sldId id="277"/>
+            <p14:sldId id="278"/>
+            <p14:sldId id="279"/>
+            <p14:sldId id="280"/>
+            <p14:sldId id="282"/>
+            <p14:sldId id="281"/>
+            <p14:sldId id="283"/>
+            <p14:sldId id="284"/>
+            <p14:sldId id="285"/>
+            <p14:sldId id="287"/>
+            <p14:sldId id="286"/>
+          </p14:sldIdLst>
+        </p14:section>
+      </p14:sectionLst>
+    </p:ext>
+    <p:ext uri="{EFAFB233-063F-42B5-8137-9DF3F51BA10A}">
+      <p15:sldGuideLst xmlns:p15="http://schemas.microsoft.com/office/powerpoint/2012/main"/>
+    </p:ext>
+  </p:extLst>
 </p:presentation>
 </file>
 
@@ -269,7 +320,7 @@
           <a:p>
             <a:fld id="{68C1468A-FBB4-D741-9607-AAB14F76B169}" type="datetimeFigureOut">
               <a:rPr lang="de-DE" smtClean="0"/>
-              <a:t>30.04.23</a:t>
+              <a:t>16.07.2025</a:t>
             </a:fld>
             <a:endParaRPr lang="de-DE"/>
           </a:p>
@@ -439,7 +490,7 @@
           <a:p>
             <a:fld id="{68C1468A-FBB4-D741-9607-AAB14F76B169}" type="datetimeFigureOut">
               <a:rPr lang="de-DE" smtClean="0"/>
-              <a:t>30.04.23</a:t>
+              <a:t>16.07.2025</a:t>
             </a:fld>
             <a:endParaRPr lang="de-DE"/>
           </a:p>
@@ -619,7 +670,7 @@
           <a:p>
             <a:fld id="{68C1468A-FBB4-D741-9607-AAB14F76B169}" type="datetimeFigureOut">
               <a:rPr lang="de-DE" smtClean="0"/>
-              <a:t>30.04.23</a:t>
+              <a:t>16.07.2025</a:t>
             </a:fld>
             <a:endParaRPr lang="de-DE"/>
           </a:p>
@@ -789,7 +840,7 @@
           <a:p>
             <a:fld id="{68C1468A-FBB4-D741-9607-AAB14F76B169}" type="datetimeFigureOut">
               <a:rPr lang="de-DE" smtClean="0"/>
-              <a:t>30.04.23</a:t>
+              <a:t>16.07.2025</a:t>
             </a:fld>
             <a:endParaRPr lang="de-DE"/>
           </a:p>
@@ -1035,7 +1086,7 @@
           <a:p>
             <a:fld id="{68C1468A-FBB4-D741-9607-AAB14F76B169}" type="datetimeFigureOut">
               <a:rPr lang="de-DE" smtClean="0"/>
-              <a:t>30.04.23</a:t>
+              <a:t>16.07.2025</a:t>
             </a:fld>
             <a:endParaRPr lang="de-DE"/>
           </a:p>
@@ -1267,7 +1318,7 @@
           <a:p>
             <a:fld id="{68C1468A-FBB4-D741-9607-AAB14F76B169}" type="datetimeFigureOut">
               <a:rPr lang="de-DE" smtClean="0"/>
-              <a:t>30.04.23</a:t>
+              <a:t>16.07.2025</a:t>
             </a:fld>
             <a:endParaRPr lang="de-DE"/>
           </a:p>
@@ -1634,7 +1685,7 @@
           <a:p>
             <a:fld id="{68C1468A-FBB4-D741-9607-AAB14F76B169}" type="datetimeFigureOut">
               <a:rPr lang="de-DE" smtClean="0"/>
-              <a:t>30.04.23</a:t>
+              <a:t>16.07.2025</a:t>
             </a:fld>
             <a:endParaRPr lang="de-DE"/>
           </a:p>
@@ -1752,7 +1803,7 @@
           <a:p>
             <a:fld id="{68C1468A-FBB4-D741-9607-AAB14F76B169}" type="datetimeFigureOut">
               <a:rPr lang="de-DE" smtClean="0"/>
-              <a:t>30.04.23</a:t>
+              <a:t>16.07.2025</a:t>
             </a:fld>
             <a:endParaRPr lang="de-DE"/>
           </a:p>
@@ -1847,7 +1898,7 @@
           <a:p>
             <a:fld id="{68C1468A-FBB4-D741-9607-AAB14F76B169}" type="datetimeFigureOut">
               <a:rPr lang="de-DE" smtClean="0"/>
-              <a:t>30.04.23</a:t>
+              <a:t>16.07.2025</a:t>
             </a:fld>
             <a:endParaRPr lang="de-DE"/>
           </a:p>
@@ -2124,7 +2175,7 @@
           <a:p>
             <a:fld id="{68C1468A-FBB4-D741-9607-AAB14F76B169}" type="datetimeFigureOut">
               <a:rPr lang="de-DE" smtClean="0"/>
-              <a:t>30.04.23</a:t>
+              <a:t>16.07.2025</a:t>
             </a:fld>
             <a:endParaRPr lang="de-DE"/>
           </a:p>
@@ -2381,7 +2432,7 @@
           <a:p>
             <a:fld id="{68C1468A-FBB4-D741-9607-AAB14F76B169}" type="datetimeFigureOut">
               <a:rPr lang="de-DE" smtClean="0"/>
-              <a:t>30.04.23</a:t>
+              <a:t>16.07.2025</a:t>
             </a:fld>
             <a:endParaRPr lang="de-DE"/>
           </a:p>
@@ -2594,7 +2645,7 @@
           <a:p>
             <a:fld id="{68C1468A-FBB4-D741-9607-AAB14F76B169}" type="datetimeFigureOut">
               <a:rPr lang="de-DE" smtClean="0"/>
-              <a:t>30.04.23</a:t>
+              <a:t>16.07.2025</a:t>
             </a:fld>
             <a:endParaRPr lang="de-DE"/>
           </a:p>
@@ -5925,7 +5976,13 @@
   <p:cSld>
     <p:spTree>
       <p:nvGrpSpPr>
-        <p:cNvPr id="1" name=""/>
+        <p:cNvPr id="1" name="">
+          <a:extLst>
+            <a:ext uri="{FF2B5EF4-FFF2-40B4-BE49-F238E27FC236}">
+              <a16:creationId xmlns:a16="http://schemas.microsoft.com/office/drawing/2014/main" id="{D021C28B-98F2-1291-04FA-610D1B0462C5}"/>
+            </a:ext>
+          </a:extLst>
+        </p:cNvPr>
         <p:cNvGrpSpPr/>
         <p:nvPr/>
       </p:nvGrpSpPr>
@@ -5942,7 +5999,7 @@
           <p:cNvPr id="4" name="Rechteck 3">
             <a:extLst>
               <a:ext uri="{FF2B5EF4-FFF2-40B4-BE49-F238E27FC236}">
-                <a16:creationId xmlns:a16="http://schemas.microsoft.com/office/drawing/2014/main" id="{8FC8D0D7-EB7B-88E4-C192-5861C72371FF}"/>
+                <a16:creationId xmlns:a16="http://schemas.microsoft.com/office/drawing/2014/main" id="{B99D007F-0139-AEB9-FBE9-36C8506AD9E2}"/>
               </a:ext>
             </a:extLst>
           </p:cNvPr>
@@ -5998,7 +6055,7 @@
           <p:cNvPr id="5" name="Textfeld 4">
             <a:extLst>
               <a:ext uri="{FF2B5EF4-FFF2-40B4-BE49-F238E27FC236}">
-                <a16:creationId xmlns:a16="http://schemas.microsoft.com/office/drawing/2014/main" id="{BDBA4B2F-CFF6-57D4-32F9-72A85833E495}"/>
+                <a16:creationId xmlns:a16="http://schemas.microsoft.com/office/drawing/2014/main" id="{58AD9F1B-7345-B48A-5C34-AE30717C441B}"/>
               </a:ext>
             </a:extLst>
           </p:cNvPr>
@@ -6030,7 +6087,7 @@
                 <a:latin typeface="Bahnschrift" panose="020B0502040204020203" pitchFamily="34" charset="0"/>
                 <a:cs typeface="Aharoni" panose="02010803020104030203" pitchFamily="2" charset="-79"/>
               </a:rPr>
-              <a:t>Event Card</a:t>
+              <a:t>Community Card</a:t>
             </a:r>
             <a:endParaRPr lang="de-DE" sz="3200" dirty="0">
               <a:solidFill>
@@ -6047,7 +6104,7 @@
           <p:cNvPr id="6" name="Textfeld 5">
             <a:extLst>
               <a:ext uri="{FF2B5EF4-FFF2-40B4-BE49-F238E27FC236}">
-                <a16:creationId xmlns:a16="http://schemas.microsoft.com/office/drawing/2014/main" id="{27FA8842-D2B4-7795-E46C-4CEB0DB0EF46}"/>
+                <a16:creationId xmlns:a16="http://schemas.microsoft.com/office/drawing/2014/main" id="{479692A9-78AA-C327-9E99-7FC1218DF918}"/>
               </a:ext>
             </a:extLst>
           </p:cNvPr>
@@ -6057,7 +6114,7 @@
         <p:spPr>
           <a:xfrm>
             <a:off x="2312751" y="2937751"/>
-            <a:ext cx="7566497" cy="1446550"/>
+            <a:ext cx="7566497" cy="1877437"/>
           </a:xfrm>
           <a:prstGeom prst="rect">
             <a:avLst/>
@@ -6072,94 +6129,14 @@
           <a:p>
             <a:pPr algn="ctr"/>
             <a:r>
-              <a:rPr lang="de-DE" sz="2800" dirty="0">
-                <a:solidFill>
-                  <a:srgbClr val="FF0000"/>
-                </a:solidFill>
-                <a:latin typeface="Bahnschrift" panose="020B0502040204020203" pitchFamily="34" charset="0"/>
-                <a:cs typeface="Aharoni" panose="02010803020104030203" pitchFamily="2" charset="-79"/>
-              </a:rPr>
-              <a:t>Move </a:t>
-            </a:r>
-            <a:r>
-              <a:rPr lang="de-DE" sz="2800" dirty="0" err="1">
-                <a:solidFill>
-                  <a:srgbClr val="FF0000"/>
-                </a:solidFill>
-                <a:latin typeface="Bahnschrift" panose="020B0502040204020203" pitchFamily="34" charset="0"/>
-                <a:cs typeface="Aharoni" panose="02010803020104030203" pitchFamily="2" charset="-79"/>
-              </a:rPr>
-              <a:t>forward</a:t>
-            </a:r>
-            <a:r>
-              <a:rPr lang="de-DE" sz="2800" dirty="0">
-                <a:solidFill>
-                  <a:srgbClr val="FF0000"/>
-                </a:solidFill>
-                <a:latin typeface="Bahnschrift" panose="020B0502040204020203" pitchFamily="34" charset="0"/>
-                <a:cs typeface="Aharoni" panose="02010803020104030203" pitchFamily="2" charset="-79"/>
-              </a:rPr>
-              <a:t> </a:t>
-            </a:r>
-            <a:r>
-              <a:rPr lang="de-DE" sz="2800" dirty="0" err="1">
-                <a:solidFill>
-                  <a:srgbClr val="FF0000"/>
-                </a:solidFill>
-                <a:latin typeface="Bahnschrift" panose="020B0502040204020203" pitchFamily="34" charset="0"/>
-                <a:cs typeface="Aharoni" panose="02010803020104030203" pitchFamily="2" charset="-79"/>
-              </a:rPr>
-              <a:t>until</a:t>
-            </a:r>
-            <a:r>
-              <a:rPr lang="de-DE" sz="2800" dirty="0">
-                <a:solidFill>
-                  <a:srgbClr val="FF0000"/>
-                </a:solidFill>
-                <a:latin typeface="Bahnschrift" panose="020B0502040204020203" pitchFamily="34" charset="0"/>
-                <a:cs typeface="Aharoni" panose="02010803020104030203" pitchFamily="2" charset="-79"/>
-              </a:rPr>
-              <a:t> </a:t>
-            </a:r>
-            <a:r>
-              <a:rPr lang="de-DE" sz="2800" dirty="0" err="1">
-                <a:solidFill>
-                  <a:srgbClr val="FF0000"/>
-                </a:solidFill>
-                <a:latin typeface="Bahnschrift" panose="020B0502040204020203" pitchFamily="34" charset="0"/>
-                <a:cs typeface="Aharoni" panose="02010803020104030203" pitchFamily="2" charset="-79"/>
-              </a:rPr>
-              <a:t>you</a:t>
-            </a:r>
-            <a:r>
-              <a:rPr lang="de-DE" sz="2800" dirty="0">
-                <a:solidFill>
-                  <a:srgbClr val="FF0000"/>
-                </a:solidFill>
-                <a:latin typeface="Bahnschrift" panose="020B0502040204020203" pitchFamily="34" charset="0"/>
-                <a:cs typeface="Aharoni" panose="02010803020104030203" pitchFamily="2" charset="-79"/>
-              </a:rPr>
-              <a:t> </a:t>
-            </a:r>
-            <a:r>
-              <a:rPr lang="de-DE" sz="2800" dirty="0" err="1">
-                <a:solidFill>
-                  <a:srgbClr val="FF0000"/>
-                </a:solidFill>
-                <a:latin typeface="Bahnschrift" panose="020B0502040204020203" pitchFamily="34" charset="0"/>
-                <a:cs typeface="Aharoni" panose="02010803020104030203" pitchFamily="2" charset="-79"/>
-              </a:rPr>
-              <a:t>reach</a:t>
-            </a:r>
-            <a:r>
-              <a:rPr lang="de-DE" sz="2800" dirty="0">
-                <a:solidFill>
-                  <a:srgbClr val="FF0000"/>
-                </a:solidFill>
-                <a:latin typeface="Bahnschrift" panose="020B0502040204020203" pitchFamily="34" charset="0"/>
-                <a:cs typeface="Aharoni" panose="02010803020104030203" pitchFamily="2" charset="-79"/>
-              </a:rPr>
-              <a:t> GO!</a:t>
+              <a:rPr lang="en-US" sz="2800" dirty="0">
+                <a:solidFill>
+                  <a:srgbClr val="FF0000"/>
+                </a:solidFill>
+                <a:latin typeface="Bahnschrift" panose="020B0502040204020203" pitchFamily="34" charset="0"/>
+                <a:cs typeface="Aharoni" panose="02010803020104030203" pitchFamily="2" charset="-79"/>
+              </a:rPr>
+              <a:t>A former Formula 1 driver tells you the sales value of your used passenger car!</a:t>
             </a:r>
           </a:p>
           <a:p>
@@ -6174,20 +6151,63 @@
           </a:p>
           <a:p>
             <a:pPr algn="ctr"/>
-            <a:endParaRPr lang="de-DE" sz="2400" dirty="0">
-              <a:solidFill>
-                <a:srgbClr val="FF0000"/>
-              </a:solidFill>
-              <a:latin typeface="Bahnschrift" panose="020B0502040204020203" pitchFamily="34" charset="0"/>
-              <a:cs typeface="Aharoni" panose="02010803020104030203" pitchFamily="2" charset="-79"/>
-            </a:endParaRPr>
+            <a:r>
+              <a:rPr lang="de-DE" sz="2400" dirty="0" err="1">
+                <a:solidFill>
+                  <a:srgbClr val="FF0000"/>
+                </a:solidFill>
+                <a:latin typeface="Bahnschrift" panose="020B0502040204020203" pitchFamily="34" charset="0"/>
+                <a:cs typeface="Aharoni" panose="02010803020104030203" pitchFamily="2" charset="-79"/>
+              </a:rPr>
+              <a:t>You</a:t>
+            </a:r>
+            <a:r>
+              <a:rPr lang="de-DE" sz="2400" dirty="0">
+                <a:solidFill>
+                  <a:srgbClr val="FF0000"/>
+                </a:solidFill>
+                <a:latin typeface="Bahnschrift" panose="020B0502040204020203" pitchFamily="34" charset="0"/>
+                <a:cs typeface="Aharoni" panose="02010803020104030203" pitchFamily="2" charset="-79"/>
+              </a:rPr>
+              <a:t> </a:t>
+            </a:r>
+            <a:r>
+              <a:rPr lang="de-DE" sz="2400" dirty="0" err="1">
+                <a:solidFill>
+                  <a:srgbClr val="FF0000"/>
+                </a:solidFill>
+                <a:latin typeface="Bahnschrift" panose="020B0502040204020203" pitchFamily="34" charset="0"/>
+                <a:cs typeface="Aharoni" panose="02010803020104030203" pitchFamily="2" charset="-79"/>
+              </a:rPr>
+              <a:t>receive</a:t>
+            </a:r>
+            <a:r>
+              <a:rPr lang="de-DE" sz="2400">
+                <a:solidFill>
+                  <a:srgbClr val="FF0000"/>
+                </a:solidFill>
+                <a:latin typeface="Bahnschrift" panose="020B0502040204020203" pitchFamily="34" charset="0"/>
+                <a:cs typeface="Aharoni" panose="02010803020104030203" pitchFamily="2" charset="-79"/>
+              </a:rPr>
+              <a:t> 500€</a:t>
+            </a:r>
+            <a:r>
+              <a:rPr lang="de-DE" sz="2400" dirty="0">
+                <a:solidFill>
+                  <a:srgbClr val="FF0000"/>
+                </a:solidFill>
+                <a:latin typeface="Bahnschrift" panose="020B0502040204020203" pitchFamily="34" charset="0"/>
+                <a:cs typeface="Aharoni" panose="02010803020104030203" pitchFamily="2" charset="-79"/>
+              </a:rPr>
+              <a:t>$</a:t>
+            </a:r>
           </a:p>
         </p:txBody>
       </p:sp>
     </p:spTree>
     <p:extLst>
       <p:ext uri="{BB962C8B-B14F-4D97-AF65-F5344CB8AC3E}">
-        <p14:creationId xmlns:p14="http://schemas.microsoft.com/office/powerpoint/2010/main" val="275061011"/>
+        <p14:creationId xmlns:p14="http://schemas.microsoft.com/office/powerpoint/2010/main" val="2664413440"/>
       </p:ext>
     </p:extLst>
   </p:cSld>
@@ -6349,6 +6369,16 @@
           <a:p>
             <a:pPr algn="ctr"/>
             <a:r>
+              <a:rPr lang="de-DE" sz="2800" dirty="0">
+                <a:solidFill>
+                  <a:srgbClr val="FF0000"/>
+                </a:solidFill>
+                <a:latin typeface="Bahnschrift" panose="020B0502040204020203" pitchFamily="34" charset="0"/>
+                <a:cs typeface="Aharoni" panose="02010803020104030203" pitchFamily="2" charset="-79"/>
+              </a:rPr>
+              <a:t>Move </a:t>
+            </a:r>
+            <a:r>
               <a:rPr lang="de-DE" sz="2800" dirty="0" err="1">
                 <a:solidFill>
                   <a:srgbClr val="FF0000"/>
@@ -6356,7 +6386,7 @@
                 <a:latin typeface="Bahnschrift" panose="020B0502040204020203" pitchFamily="34" charset="0"/>
                 <a:cs typeface="Aharoni" panose="02010803020104030203" pitchFamily="2" charset="-79"/>
               </a:rPr>
-              <a:t>You</a:t>
+              <a:t>forward</a:t>
             </a:r>
             <a:r>
               <a:rPr lang="de-DE" sz="2800" dirty="0">
@@ -6376,7 +6406,7 @@
                 <a:latin typeface="Bahnschrift" panose="020B0502040204020203" pitchFamily="34" charset="0"/>
                 <a:cs typeface="Aharoni" panose="02010803020104030203" pitchFamily="2" charset="-79"/>
               </a:rPr>
-              <a:t>are</a:t>
+              <a:t>until</a:t>
             </a:r>
             <a:r>
               <a:rPr lang="de-DE" sz="2800" dirty="0">
@@ -6386,7 +6416,7 @@
                 <a:latin typeface="Bahnschrift" panose="020B0502040204020203" pitchFamily="34" charset="0"/>
                 <a:cs typeface="Aharoni" panose="02010803020104030203" pitchFamily="2" charset="-79"/>
               </a:rPr>
-              <a:t> in </a:t>
+              <a:t> </a:t>
             </a:r>
             <a:r>
               <a:rPr lang="de-DE" sz="2800" dirty="0" err="1">
@@ -6396,7 +6426,7 @@
                 <a:latin typeface="Bahnschrift" panose="020B0502040204020203" pitchFamily="34" charset="0"/>
                 <a:cs typeface="Aharoni" panose="02010803020104030203" pitchFamily="2" charset="-79"/>
               </a:rPr>
-              <a:t>debt</a:t>
+              <a:t>you</a:t>
             </a:r>
             <a:r>
               <a:rPr lang="de-DE" sz="2800" dirty="0">
@@ -6406,7 +6436,27 @@
                 <a:latin typeface="Bahnschrift" panose="020B0502040204020203" pitchFamily="34" charset="0"/>
                 <a:cs typeface="Aharoni" panose="02010803020104030203" pitchFamily="2" charset="-79"/>
               </a:rPr>
-              <a:t>!</a:t>
+              <a:t> </a:t>
+            </a:r>
+            <a:r>
+              <a:rPr lang="de-DE" sz="2800" dirty="0" err="1">
+                <a:solidFill>
+                  <a:srgbClr val="FF0000"/>
+                </a:solidFill>
+                <a:latin typeface="Bahnschrift" panose="020B0502040204020203" pitchFamily="34" charset="0"/>
+                <a:cs typeface="Aharoni" panose="02010803020104030203" pitchFamily="2" charset="-79"/>
+              </a:rPr>
+              <a:t>reach</a:t>
+            </a:r>
+            <a:r>
+              <a:rPr lang="de-DE" sz="2800" dirty="0">
+                <a:solidFill>
+                  <a:srgbClr val="FF0000"/>
+                </a:solidFill>
+                <a:latin typeface="Bahnschrift" panose="020B0502040204020203" pitchFamily="34" charset="0"/>
+                <a:cs typeface="Aharoni" panose="02010803020104030203" pitchFamily="2" charset="-79"/>
+              </a:rPr>
+              <a:t> GO!</a:t>
             </a:r>
           </a:p>
           <a:p>
@@ -6421,23 +6471,20 @@
           </a:p>
           <a:p>
             <a:pPr algn="ctr"/>
-            <a:r>
-              <a:rPr lang="de-DE" sz="2400" dirty="0">
-                <a:solidFill>
-                  <a:srgbClr val="FF0000"/>
-                </a:solidFill>
-                <a:latin typeface="Bahnschrift" panose="020B0502040204020203" pitchFamily="34" charset="0"/>
-                <a:cs typeface="Aharoni" panose="02010803020104030203" pitchFamily="2" charset="-79"/>
-              </a:rPr>
-              <a:t>Pay 150€$</a:t>
-            </a:r>
+            <a:endParaRPr lang="de-DE" sz="2400" dirty="0">
+              <a:solidFill>
+                <a:srgbClr val="FF0000"/>
+              </a:solidFill>
+              <a:latin typeface="Bahnschrift" panose="020B0502040204020203" pitchFamily="34" charset="0"/>
+              <a:cs typeface="Aharoni" panose="02010803020104030203" pitchFamily="2" charset="-79"/>
+            </a:endParaRPr>
           </a:p>
         </p:txBody>
       </p:sp>
     </p:spTree>
     <p:extLst>
       <p:ext uri="{BB962C8B-B14F-4D97-AF65-F5344CB8AC3E}">
-        <p14:creationId xmlns:p14="http://schemas.microsoft.com/office/powerpoint/2010/main" val="2947272769"/>
+        <p14:creationId xmlns:p14="http://schemas.microsoft.com/office/powerpoint/2010/main" val="275061011"/>
       </p:ext>
     </p:extLst>
   </p:cSld>
@@ -6584,7 +6631,7 @@
         <p:spPr>
           <a:xfrm>
             <a:off x="2312751" y="2937751"/>
-            <a:ext cx="7566497" cy="2246769"/>
+            <a:ext cx="7566497" cy="1446550"/>
           </a:xfrm>
           <a:prstGeom prst="rect">
             <a:avLst/>
@@ -6636,7 +6683,7 @@
                 <a:latin typeface="Bahnschrift" panose="020B0502040204020203" pitchFamily="34" charset="0"/>
                 <a:cs typeface="Aharoni" panose="02010803020104030203" pitchFamily="2" charset="-79"/>
               </a:rPr>
-              <a:t> </a:t>
+              <a:t> in </a:t>
             </a:r>
             <a:r>
               <a:rPr lang="de-DE" sz="2800" dirty="0" err="1">
@@ -6646,7 +6693,7 @@
                 <a:latin typeface="Bahnschrift" panose="020B0502040204020203" pitchFamily="34" charset="0"/>
                 <a:cs typeface="Aharoni" panose="02010803020104030203" pitchFamily="2" charset="-79"/>
               </a:rPr>
-              <a:t>volunteering</a:t>
+              <a:t>debt</a:t>
             </a:r>
             <a:r>
               <a:rPr lang="de-DE" sz="2800" dirty="0">
@@ -6656,127 +6703,7 @@
                 <a:latin typeface="Bahnschrift" panose="020B0502040204020203" pitchFamily="34" charset="0"/>
                 <a:cs typeface="Aharoni" panose="02010803020104030203" pitchFamily="2" charset="-79"/>
               </a:rPr>
-              <a:t> </a:t>
-            </a:r>
-            <a:r>
-              <a:rPr lang="de-DE" sz="2800" dirty="0" err="1">
-                <a:solidFill>
-                  <a:srgbClr val="FF0000"/>
-                </a:solidFill>
-                <a:latin typeface="Bahnschrift" panose="020B0502040204020203" pitchFamily="34" charset="0"/>
-                <a:cs typeface="Aharoni" panose="02010803020104030203" pitchFamily="2" charset="-79"/>
-              </a:rPr>
-              <a:t>to</a:t>
-            </a:r>
-            <a:r>
-              <a:rPr lang="de-DE" sz="2800" dirty="0">
-                <a:solidFill>
-                  <a:srgbClr val="FF0000"/>
-                </a:solidFill>
-                <a:latin typeface="Bahnschrift" panose="020B0502040204020203" pitchFamily="34" charset="0"/>
-                <a:cs typeface="Aharoni" panose="02010803020104030203" pitchFamily="2" charset="-79"/>
-              </a:rPr>
-              <a:t> </a:t>
-            </a:r>
-            <a:r>
-              <a:rPr lang="de-DE" sz="2800" dirty="0" err="1">
-                <a:solidFill>
-                  <a:srgbClr val="FF0000"/>
-                </a:solidFill>
-                <a:latin typeface="Bahnschrift" panose="020B0502040204020203" pitchFamily="34" charset="0"/>
-                <a:cs typeface="Aharoni" panose="02010803020104030203" pitchFamily="2" charset="-79"/>
-              </a:rPr>
-              <a:t>aid</a:t>
-            </a:r>
-            <a:r>
-              <a:rPr lang="de-DE" sz="2800" dirty="0">
-                <a:solidFill>
-                  <a:srgbClr val="FF0000"/>
-                </a:solidFill>
-                <a:latin typeface="Bahnschrift" panose="020B0502040204020203" pitchFamily="34" charset="0"/>
-                <a:cs typeface="Aharoni" panose="02010803020104030203" pitchFamily="2" charset="-79"/>
-              </a:rPr>
-              <a:t> </a:t>
-            </a:r>
-            <a:r>
-              <a:rPr lang="de-DE" sz="2800" dirty="0" err="1">
-                <a:solidFill>
-                  <a:srgbClr val="FF0000"/>
-                </a:solidFill>
-                <a:latin typeface="Bahnschrift" panose="020B0502040204020203" pitchFamily="34" charset="0"/>
-                <a:cs typeface="Aharoni" panose="02010803020104030203" pitchFamily="2" charset="-79"/>
-              </a:rPr>
-              <a:t>with</a:t>
-            </a:r>
-            <a:r>
-              <a:rPr lang="de-DE" sz="2800" dirty="0">
-                <a:solidFill>
-                  <a:srgbClr val="FF0000"/>
-                </a:solidFill>
-                <a:latin typeface="Bahnschrift" panose="020B0502040204020203" pitchFamily="34" charset="0"/>
-                <a:cs typeface="Aharoni" panose="02010803020104030203" pitchFamily="2" charset="-79"/>
-              </a:rPr>
-              <a:t> </a:t>
-            </a:r>
-            <a:r>
-              <a:rPr lang="de-DE" sz="2800" dirty="0" err="1">
-                <a:solidFill>
-                  <a:srgbClr val="FF0000"/>
-                </a:solidFill>
-                <a:latin typeface="Bahnschrift" panose="020B0502040204020203" pitchFamily="34" charset="0"/>
-                <a:cs typeface="Aharoni" panose="02010803020104030203" pitchFamily="2" charset="-79"/>
-              </a:rPr>
-              <a:t>maintaining</a:t>
-            </a:r>
-            <a:r>
-              <a:rPr lang="de-DE" sz="2800" dirty="0">
-                <a:solidFill>
-                  <a:srgbClr val="FF0000"/>
-                </a:solidFill>
-                <a:latin typeface="Bahnschrift" panose="020B0502040204020203" pitchFamily="34" charset="0"/>
-                <a:cs typeface="Aharoni" panose="02010803020104030203" pitchFamily="2" charset="-79"/>
-              </a:rPr>
-              <a:t> </a:t>
-            </a:r>
-            <a:r>
-              <a:rPr lang="de-DE" sz="2800" dirty="0" err="1">
-                <a:solidFill>
-                  <a:srgbClr val="FF0000"/>
-                </a:solidFill>
-                <a:latin typeface="Bahnschrift" panose="020B0502040204020203" pitchFamily="34" charset="0"/>
-                <a:cs typeface="Aharoni" panose="02010803020104030203" pitchFamily="2" charset="-79"/>
-              </a:rPr>
-              <a:t>your</a:t>
-            </a:r>
-            <a:r>
-              <a:rPr lang="de-DE" sz="2800" dirty="0">
-                <a:solidFill>
-                  <a:srgbClr val="FF0000"/>
-                </a:solidFill>
-                <a:latin typeface="Bahnschrift" panose="020B0502040204020203" pitchFamily="34" charset="0"/>
-                <a:cs typeface="Aharoni" panose="02010803020104030203" pitchFamily="2" charset="-79"/>
-              </a:rPr>
-              <a:t> </a:t>
-            </a:r>
-            <a:r>
-              <a:rPr lang="de-DE" sz="2800" dirty="0" err="1">
-                <a:solidFill>
-                  <a:srgbClr val="FF0000"/>
-                </a:solidFill>
-                <a:latin typeface="Bahnschrift" panose="020B0502040204020203" pitchFamily="34" charset="0"/>
-                <a:cs typeface="Aharoni" panose="02010803020104030203" pitchFamily="2" charset="-79"/>
-              </a:rPr>
-              <a:t>roads</a:t>
-            </a:r>
-            <a:r>
-              <a:rPr lang="de-DE" sz="2800" dirty="0">
-                <a:solidFill>
-                  <a:srgbClr val="FF0000"/>
-                </a:solidFill>
-                <a:latin typeface="Bahnschrift" panose="020B0502040204020203" pitchFamily="34" charset="0"/>
-                <a:cs typeface="Aharoni" panose="02010803020104030203" pitchFamily="2" charset="-79"/>
-              </a:rPr>
-              <a:t>.</a:t>
+              <a:t>!</a:t>
             </a:r>
           </a:p>
           <a:p>
@@ -6799,62 +6726,15 @@
                 <a:latin typeface="Bahnschrift" panose="020B0502040204020203" pitchFamily="34" charset="0"/>
                 <a:cs typeface="Aharoni" panose="02010803020104030203" pitchFamily="2" charset="-79"/>
               </a:rPr>
-              <a:t>Pay 40€$ / </a:t>
-            </a:r>
-            <a:r>
-              <a:rPr lang="de-DE" sz="2400" dirty="0" err="1">
-                <a:solidFill>
-                  <a:srgbClr val="FF0000"/>
-                </a:solidFill>
-                <a:latin typeface="Bahnschrift" panose="020B0502040204020203" pitchFamily="34" charset="0"/>
-                <a:cs typeface="Aharoni" panose="02010803020104030203" pitchFamily="2" charset="-79"/>
-              </a:rPr>
-              <a:t>house</a:t>
-            </a:r>
-            <a:endParaRPr lang="de-DE" sz="2400" dirty="0">
-              <a:solidFill>
-                <a:srgbClr val="FF0000"/>
-              </a:solidFill>
-              <a:latin typeface="Bahnschrift" panose="020B0502040204020203" pitchFamily="34" charset="0"/>
-              <a:cs typeface="Aharoni" panose="02010803020104030203" pitchFamily="2" charset="-79"/>
-            </a:endParaRPr>
-          </a:p>
-          <a:p>
-            <a:pPr algn="ctr"/>
-            <a:r>
-              <a:rPr lang="de-DE" sz="2400" dirty="0">
-                <a:solidFill>
-                  <a:srgbClr val="FF0000"/>
-                </a:solidFill>
-                <a:latin typeface="Bahnschrift" panose="020B0502040204020203" pitchFamily="34" charset="0"/>
-                <a:cs typeface="Aharoni" panose="02010803020104030203" pitchFamily="2" charset="-79"/>
-              </a:rPr>
-              <a:t>Pay 115€$ / </a:t>
-            </a:r>
-            <a:r>
-              <a:rPr lang="de-DE" sz="2400" dirty="0" err="1">
-                <a:solidFill>
-                  <a:srgbClr val="FF0000"/>
-                </a:solidFill>
-                <a:latin typeface="Bahnschrift" panose="020B0502040204020203" pitchFamily="34" charset="0"/>
-                <a:cs typeface="Aharoni" panose="02010803020104030203" pitchFamily="2" charset="-79"/>
-              </a:rPr>
-              <a:t>hotel</a:t>
-            </a:r>
-            <a:endParaRPr lang="de-DE" sz="2400" dirty="0">
-              <a:solidFill>
-                <a:srgbClr val="FF0000"/>
-              </a:solidFill>
-              <a:latin typeface="Bahnschrift" panose="020B0502040204020203" pitchFamily="34" charset="0"/>
-              <a:cs typeface="Aharoni" panose="02010803020104030203" pitchFamily="2" charset="-79"/>
-            </a:endParaRPr>
+              <a:t>Pay 150€$</a:t>
+            </a:r>
           </a:p>
         </p:txBody>
       </p:sp>
     </p:spTree>
     <p:extLst>
       <p:ext uri="{BB962C8B-B14F-4D97-AF65-F5344CB8AC3E}">
-        <p14:creationId xmlns:p14="http://schemas.microsoft.com/office/powerpoint/2010/main" val="2197717669"/>
+        <p14:creationId xmlns:p14="http://schemas.microsoft.com/office/powerpoint/2010/main" val="2947272769"/>
       </p:ext>
     </p:extLst>
   </p:cSld>
@@ -7291,7 +7171,7 @@
         <p:spPr>
           <a:xfrm>
             <a:off x="2312751" y="2937751"/>
-            <a:ext cx="7566497" cy="1446550"/>
+            <a:ext cx="7566497" cy="2246769"/>
           </a:xfrm>
           <a:prstGeom prst="rect">
             <a:avLst/>
@@ -7306,6 +7186,16 @@
           <a:p>
             <a:pPr algn="ctr"/>
             <a:r>
+              <a:rPr lang="de-DE" sz="2800" dirty="0" err="1">
+                <a:solidFill>
+                  <a:srgbClr val="FF0000"/>
+                </a:solidFill>
+                <a:latin typeface="Bahnschrift" panose="020B0502040204020203" pitchFamily="34" charset="0"/>
+                <a:cs typeface="Aharoni" panose="02010803020104030203" pitchFamily="2" charset="-79"/>
+              </a:rPr>
+              <a:t>You</a:t>
+            </a:r>
+            <a:r>
               <a:rPr lang="de-DE" sz="2800" dirty="0">
                 <a:solidFill>
                   <a:srgbClr val="FF0000"/>
@@ -7313,7 +7203,7 @@
                 <a:latin typeface="Bahnschrift" panose="020B0502040204020203" pitchFamily="34" charset="0"/>
                 <a:cs typeface="Aharoni" panose="02010803020104030203" pitchFamily="2" charset="-79"/>
               </a:rPr>
-              <a:t>The </a:t>
+              <a:t> </a:t>
             </a:r>
             <a:r>
               <a:rPr lang="de-DE" sz="2800" dirty="0" err="1">
@@ -7323,7 +7213,7 @@
                 <a:latin typeface="Bahnschrift" panose="020B0502040204020203" pitchFamily="34" charset="0"/>
                 <a:cs typeface="Aharoni" panose="02010803020104030203" pitchFamily="2" charset="-79"/>
               </a:rPr>
-              <a:t>bank</a:t>
+              <a:t>are</a:t>
             </a:r>
             <a:r>
               <a:rPr lang="de-DE" sz="2800" dirty="0">
@@ -7343,7 +7233,7 @@
                 <a:latin typeface="Bahnschrift" panose="020B0502040204020203" pitchFamily="34" charset="0"/>
                 <a:cs typeface="Aharoni" panose="02010803020104030203" pitchFamily="2" charset="-79"/>
               </a:rPr>
-              <a:t>pays</a:t>
+              <a:t>volunteering</a:t>
             </a:r>
             <a:r>
               <a:rPr lang="de-DE" sz="2800" dirty="0">
@@ -7363,7 +7253,7 @@
                 <a:latin typeface="Bahnschrift" panose="020B0502040204020203" pitchFamily="34" charset="0"/>
                 <a:cs typeface="Aharoni" panose="02010803020104030203" pitchFamily="2" charset="-79"/>
               </a:rPr>
-              <a:t>you</a:t>
+              <a:t>to</a:t>
             </a:r>
             <a:r>
               <a:rPr lang="de-DE" sz="2800" dirty="0">
@@ -7383,7 +7273,7 @@
                 <a:latin typeface="Bahnschrift" panose="020B0502040204020203" pitchFamily="34" charset="0"/>
                 <a:cs typeface="Aharoni" panose="02010803020104030203" pitchFamily="2" charset="-79"/>
               </a:rPr>
-              <a:t>interest</a:t>
+              <a:t>aid</a:t>
             </a:r>
             <a:r>
               <a:rPr lang="de-DE" sz="2800" dirty="0">
@@ -7393,7 +7283,87 @@
                 <a:latin typeface="Bahnschrift" panose="020B0502040204020203" pitchFamily="34" charset="0"/>
                 <a:cs typeface="Aharoni" panose="02010803020104030203" pitchFamily="2" charset="-79"/>
               </a:rPr>
-              <a:t>!</a:t>
+              <a:t> </a:t>
+            </a:r>
+            <a:r>
+              <a:rPr lang="de-DE" sz="2800" dirty="0" err="1">
+                <a:solidFill>
+                  <a:srgbClr val="FF0000"/>
+                </a:solidFill>
+                <a:latin typeface="Bahnschrift" panose="020B0502040204020203" pitchFamily="34" charset="0"/>
+                <a:cs typeface="Aharoni" panose="02010803020104030203" pitchFamily="2" charset="-79"/>
+              </a:rPr>
+              <a:t>with</a:t>
+            </a:r>
+            <a:r>
+              <a:rPr lang="de-DE" sz="2800" dirty="0">
+                <a:solidFill>
+                  <a:srgbClr val="FF0000"/>
+                </a:solidFill>
+                <a:latin typeface="Bahnschrift" panose="020B0502040204020203" pitchFamily="34" charset="0"/>
+                <a:cs typeface="Aharoni" panose="02010803020104030203" pitchFamily="2" charset="-79"/>
+              </a:rPr>
+              <a:t> </a:t>
+            </a:r>
+            <a:r>
+              <a:rPr lang="de-DE" sz="2800" dirty="0" err="1">
+                <a:solidFill>
+                  <a:srgbClr val="FF0000"/>
+                </a:solidFill>
+                <a:latin typeface="Bahnschrift" panose="020B0502040204020203" pitchFamily="34" charset="0"/>
+                <a:cs typeface="Aharoni" panose="02010803020104030203" pitchFamily="2" charset="-79"/>
+              </a:rPr>
+              <a:t>maintaining</a:t>
+            </a:r>
+            <a:r>
+              <a:rPr lang="de-DE" sz="2800" dirty="0">
+                <a:solidFill>
+                  <a:srgbClr val="FF0000"/>
+                </a:solidFill>
+                <a:latin typeface="Bahnschrift" panose="020B0502040204020203" pitchFamily="34" charset="0"/>
+                <a:cs typeface="Aharoni" panose="02010803020104030203" pitchFamily="2" charset="-79"/>
+              </a:rPr>
+              <a:t> </a:t>
+            </a:r>
+            <a:r>
+              <a:rPr lang="de-DE" sz="2800" dirty="0" err="1">
+                <a:solidFill>
+                  <a:srgbClr val="FF0000"/>
+                </a:solidFill>
+                <a:latin typeface="Bahnschrift" panose="020B0502040204020203" pitchFamily="34" charset="0"/>
+                <a:cs typeface="Aharoni" panose="02010803020104030203" pitchFamily="2" charset="-79"/>
+              </a:rPr>
+              <a:t>your</a:t>
+            </a:r>
+            <a:r>
+              <a:rPr lang="de-DE" sz="2800" dirty="0">
+                <a:solidFill>
+                  <a:srgbClr val="FF0000"/>
+                </a:solidFill>
+                <a:latin typeface="Bahnschrift" panose="020B0502040204020203" pitchFamily="34" charset="0"/>
+                <a:cs typeface="Aharoni" panose="02010803020104030203" pitchFamily="2" charset="-79"/>
+              </a:rPr>
+              <a:t> </a:t>
+            </a:r>
+            <a:r>
+              <a:rPr lang="de-DE" sz="2800" dirty="0" err="1">
+                <a:solidFill>
+                  <a:srgbClr val="FF0000"/>
+                </a:solidFill>
+                <a:latin typeface="Bahnschrift" panose="020B0502040204020203" pitchFamily="34" charset="0"/>
+                <a:cs typeface="Aharoni" panose="02010803020104030203" pitchFamily="2" charset="-79"/>
+              </a:rPr>
+              <a:t>roads</a:t>
+            </a:r>
+            <a:r>
+              <a:rPr lang="de-DE" sz="2800" dirty="0">
+                <a:solidFill>
+                  <a:srgbClr val="FF0000"/>
+                </a:solidFill>
+                <a:latin typeface="Bahnschrift" panose="020B0502040204020203" pitchFamily="34" charset="0"/>
+                <a:cs typeface="Aharoni" panose="02010803020104030203" pitchFamily="2" charset="-79"/>
+              </a:rPr>
+              <a:t>.</a:t>
             </a:r>
           </a:p>
           <a:p>
@@ -7409,6 +7379,16 @@
           <a:p>
             <a:pPr algn="ctr"/>
             <a:r>
+              <a:rPr lang="de-DE" sz="2400" dirty="0">
+                <a:solidFill>
+                  <a:srgbClr val="FF0000"/>
+                </a:solidFill>
+                <a:latin typeface="Bahnschrift" panose="020B0502040204020203" pitchFamily="34" charset="0"/>
+                <a:cs typeface="Aharoni" panose="02010803020104030203" pitchFamily="2" charset="-79"/>
+              </a:rPr>
+              <a:t>Pay 40€$ / </a:t>
+            </a:r>
+            <a:r>
               <a:rPr lang="de-DE" sz="2400" dirty="0" err="1">
                 <a:solidFill>
                   <a:srgbClr val="FF0000"/>
@@ -7416,8 +7396,18 @@
                 <a:latin typeface="Bahnschrift" panose="020B0502040204020203" pitchFamily="34" charset="0"/>
                 <a:cs typeface="Aharoni" panose="02010803020104030203" pitchFamily="2" charset="-79"/>
               </a:rPr>
-              <a:t>You</a:t>
-            </a:r>
+              <a:t>house</a:t>
+            </a:r>
+            <a:endParaRPr lang="de-DE" sz="2400" dirty="0">
+              <a:solidFill>
+                <a:srgbClr val="FF0000"/>
+              </a:solidFill>
+              <a:latin typeface="Bahnschrift" panose="020B0502040204020203" pitchFamily="34" charset="0"/>
+              <a:cs typeface="Aharoni" panose="02010803020104030203" pitchFamily="2" charset="-79"/>
+            </a:endParaRPr>
+          </a:p>
+          <a:p>
+            <a:pPr algn="ctr"/>
             <a:r>
               <a:rPr lang="de-DE" sz="2400" dirty="0">
                 <a:solidFill>
@@ -7426,7 +7416,7 @@
                 <a:latin typeface="Bahnschrift" panose="020B0502040204020203" pitchFamily="34" charset="0"/>
                 <a:cs typeface="Aharoni" panose="02010803020104030203" pitchFamily="2" charset="-79"/>
               </a:rPr>
-              <a:t> </a:t>
+              <a:t>Pay 115€$ / </a:t>
             </a:r>
             <a:r>
               <a:rPr lang="de-DE" sz="2400" dirty="0" err="1">
@@ -7436,25 +7426,22 @@
                 <a:latin typeface="Bahnschrift" panose="020B0502040204020203" pitchFamily="34" charset="0"/>
                 <a:cs typeface="Aharoni" panose="02010803020104030203" pitchFamily="2" charset="-79"/>
               </a:rPr>
-              <a:t>receive</a:t>
-            </a:r>
-            <a:r>
-              <a:rPr lang="de-DE" sz="2400" dirty="0">
-                <a:solidFill>
-                  <a:srgbClr val="FF0000"/>
-                </a:solidFill>
-                <a:latin typeface="Bahnschrift" panose="020B0502040204020203" pitchFamily="34" charset="0"/>
-                <a:cs typeface="Aharoni" panose="02010803020104030203" pitchFamily="2" charset="-79"/>
-              </a:rPr>
-              <a:t> 150€$</a:t>
-            </a:r>
+              <a:t>hotel</a:t>
+            </a:r>
+            <a:endParaRPr lang="de-DE" sz="2400" dirty="0">
+              <a:solidFill>
+                <a:srgbClr val="FF0000"/>
+              </a:solidFill>
+              <a:latin typeface="Bahnschrift" panose="020B0502040204020203" pitchFamily="34" charset="0"/>
+              <a:cs typeface="Aharoni" panose="02010803020104030203" pitchFamily="2" charset="-79"/>
+            </a:endParaRPr>
           </a:p>
         </p:txBody>
       </p:sp>
     </p:spTree>
     <p:extLst>
       <p:ext uri="{BB962C8B-B14F-4D97-AF65-F5344CB8AC3E}">
-        <p14:creationId xmlns:p14="http://schemas.microsoft.com/office/powerpoint/2010/main" val="3789431785"/>
+        <p14:creationId xmlns:p14="http://schemas.microsoft.com/office/powerpoint/2010/main" val="2197717669"/>
       </p:ext>
     </p:extLst>
   </p:cSld>
@@ -7601,7 +7588,7 @@
         <p:spPr>
           <a:xfrm>
             <a:off x="2312751" y="2937751"/>
-            <a:ext cx="7566497" cy="1877437"/>
+            <a:ext cx="7566497" cy="1446550"/>
           </a:xfrm>
           <a:prstGeom prst="rect">
             <a:avLst/>
@@ -7616,6 +7603,16 @@
           <a:p>
             <a:pPr algn="ctr"/>
             <a:r>
+              <a:rPr lang="de-DE" sz="2800" dirty="0">
+                <a:solidFill>
+                  <a:srgbClr val="FF0000"/>
+                </a:solidFill>
+                <a:latin typeface="Bahnschrift" panose="020B0502040204020203" pitchFamily="34" charset="0"/>
+                <a:cs typeface="Aharoni" panose="02010803020104030203" pitchFamily="2" charset="-79"/>
+              </a:rPr>
+              <a:t>The </a:t>
+            </a:r>
+            <a:r>
               <a:rPr lang="de-DE" sz="2800" dirty="0" err="1">
                 <a:solidFill>
                   <a:srgbClr val="FF0000"/>
@@ -7623,7 +7620,7 @@
                 <a:latin typeface="Bahnschrift" panose="020B0502040204020203" pitchFamily="34" charset="0"/>
                 <a:cs typeface="Aharoni" panose="02010803020104030203" pitchFamily="2" charset="-79"/>
               </a:rPr>
-              <a:t>You</a:t>
+              <a:t>bank</a:t>
             </a:r>
             <a:r>
               <a:rPr lang="de-DE" sz="2800" dirty="0">
@@ -7643,7 +7640,7 @@
                 <a:latin typeface="Bahnschrift" panose="020B0502040204020203" pitchFamily="34" charset="0"/>
                 <a:cs typeface="Aharoni" panose="02010803020104030203" pitchFamily="2" charset="-79"/>
               </a:rPr>
-              <a:t>bribed</a:t>
+              <a:t>pays</a:t>
             </a:r>
             <a:r>
               <a:rPr lang="de-DE" sz="2800" dirty="0">
@@ -7663,7 +7660,7 @@
                 <a:latin typeface="Bahnschrift" panose="020B0502040204020203" pitchFamily="34" charset="0"/>
                 <a:cs typeface="Aharoni" panose="02010803020104030203" pitchFamily="2" charset="-79"/>
               </a:rPr>
-              <a:t>the</a:t>
+              <a:t>you</a:t>
             </a:r>
             <a:r>
               <a:rPr lang="de-DE" sz="2800" dirty="0">
@@ -7683,7 +7680,7 @@
                 <a:latin typeface="Bahnschrift" panose="020B0502040204020203" pitchFamily="34" charset="0"/>
                 <a:cs typeface="Aharoni" panose="02010803020104030203" pitchFamily="2" charset="-79"/>
               </a:rPr>
-              <a:t>other</a:t>
+              <a:t>interest</a:t>
             </a:r>
             <a:r>
               <a:rPr lang="de-DE" sz="2800" dirty="0">
@@ -7693,187 +7690,7 @@
                 <a:latin typeface="Bahnschrift" panose="020B0502040204020203" pitchFamily="34" charset="0"/>
                 <a:cs typeface="Aharoni" panose="02010803020104030203" pitchFamily="2" charset="-79"/>
               </a:rPr>
-              <a:t> </a:t>
-            </a:r>
-            <a:r>
-              <a:rPr lang="de-DE" sz="2800" dirty="0" err="1">
-                <a:solidFill>
-                  <a:srgbClr val="FF0000"/>
-                </a:solidFill>
-                <a:latin typeface="Bahnschrift" panose="020B0502040204020203" pitchFamily="34" charset="0"/>
-                <a:cs typeface="Aharoni" panose="02010803020104030203" pitchFamily="2" charset="-79"/>
-              </a:rPr>
-              <a:t>players</a:t>
-            </a:r>
-            <a:r>
-              <a:rPr lang="de-DE" sz="2800" dirty="0">
-                <a:solidFill>
-                  <a:srgbClr val="FF0000"/>
-                </a:solidFill>
-                <a:latin typeface="Bahnschrift" panose="020B0502040204020203" pitchFamily="34" charset="0"/>
-                <a:cs typeface="Aharoni" panose="02010803020104030203" pitchFamily="2" charset="-79"/>
-              </a:rPr>
-              <a:t> </a:t>
-            </a:r>
-            <a:r>
-              <a:rPr lang="de-DE" sz="2800" dirty="0" err="1">
-                <a:solidFill>
-                  <a:srgbClr val="FF0000"/>
-                </a:solidFill>
-                <a:latin typeface="Bahnschrift" panose="020B0502040204020203" pitchFamily="34" charset="0"/>
-                <a:cs typeface="Aharoni" panose="02010803020104030203" pitchFamily="2" charset="-79"/>
-              </a:rPr>
-              <a:t>to</a:t>
-            </a:r>
-            <a:r>
-              <a:rPr lang="de-DE" sz="2800" dirty="0">
-                <a:solidFill>
-                  <a:srgbClr val="FF0000"/>
-                </a:solidFill>
-                <a:latin typeface="Bahnschrift" panose="020B0502040204020203" pitchFamily="34" charset="0"/>
-                <a:cs typeface="Aharoni" panose="02010803020104030203" pitchFamily="2" charset="-79"/>
-              </a:rPr>
-              <a:t> </a:t>
-            </a:r>
-            <a:r>
-              <a:rPr lang="de-DE" sz="2800" dirty="0" err="1">
-                <a:solidFill>
-                  <a:srgbClr val="FF0000"/>
-                </a:solidFill>
-                <a:latin typeface="Bahnschrift" panose="020B0502040204020203" pitchFamily="34" charset="0"/>
-                <a:cs typeface="Aharoni" panose="02010803020104030203" pitchFamily="2" charset="-79"/>
-              </a:rPr>
-              <a:t>become</a:t>
-            </a:r>
-            <a:r>
-              <a:rPr lang="de-DE" sz="2800" dirty="0">
-                <a:solidFill>
-                  <a:srgbClr val="FF0000"/>
-                </a:solidFill>
-                <a:latin typeface="Bahnschrift" panose="020B0502040204020203" pitchFamily="34" charset="0"/>
-                <a:cs typeface="Aharoni" panose="02010803020104030203" pitchFamily="2" charset="-79"/>
-              </a:rPr>
-              <a:t> </a:t>
-            </a:r>
-            <a:r>
-              <a:rPr lang="de-DE" sz="2800" dirty="0" err="1">
-                <a:solidFill>
-                  <a:srgbClr val="FF0000"/>
-                </a:solidFill>
-                <a:latin typeface="Bahnschrift" panose="020B0502040204020203" pitchFamily="34" charset="0"/>
-                <a:cs typeface="Aharoni" panose="02010803020104030203" pitchFamily="2" charset="-79"/>
-              </a:rPr>
-              <a:t>part</a:t>
-            </a:r>
-            <a:r>
-              <a:rPr lang="de-DE" sz="2800" dirty="0">
-                <a:solidFill>
-                  <a:srgbClr val="FF0000"/>
-                </a:solidFill>
-                <a:latin typeface="Bahnschrift" panose="020B0502040204020203" pitchFamily="34" charset="0"/>
-                <a:cs typeface="Aharoni" panose="02010803020104030203" pitchFamily="2" charset="-79"/>
-              </a:rPr>
-              <a:t> </a:t>
-            </a:r>
-            <a:r>
-              <a:rPr lang="de-DE" sz="2800" dirty="0" err="1">
-                <a:solidFill>
-                  <a:srgbClr val="FF0000"/>
-                </a:solidFill>
-                <a:latin typeface="Bahnschrift" panose="020B0502040204020203" pitchFamily="34" charset="0"/>
-                <a:cs typeface="Aharoni" panose="02010803020104030203" pitchFamily="2" charset="-79"/>
-              </a:rPr>
-              <a:t>of</a:t>
-            </a:r>
-            <a:r>
-              <a:rPr lang="de-DE" sz="2800" dirty="0">
-                <a:solidFill>
-                  <a:srgbClr val="FF0000"/>
-                </a:solidFill>
-                <a:latin typeface="Bahnschrift" panose="020B0502040204020203" pitchFamily="34" charset="0"/>
-                <a:cs typeface="Aharoni" panose="02010803020104030203" pitchFamily="2" charset="-79"/>
-              </a:rPr>
-              <a:t> </a:t>
-            </a:r>
-            <a:r>
-              <a:rPr lang="de-DE" sz="2800" dirty="0" err="1">
-                <a:solidFill>
-                  <a:srgbClr val="FF0000"/>
-                </a:solidFill>
-                <a:latin typeface="Bahnschrift" panose="020B0502040204020203" pitchFamily="34" charset="0"/>
-                <a:cs typeface="Aharoni" panose="02010803020104030203" pitchFamily="2" charset="-79"/>
-              </a:rPr>
-              <a:t>the</a:t>
-            </a:r>
-            <a:r>
-              <a:rPr lang="de-DE" sz="2800" dirty="0">
-                <a:solidFill>
-                  <a:srgbClr val="FF0000"/>
-                </a:solidFill>
-                <a:latin typeface="Bahnschrift" panose="020B0502040204020203" pitchFamily="34" charset="0"/>
-                <a:cs typeface="Aharoni" panose="02010803020104030203" pitchFamily="2" charset="-79"/>
-              </a:rPr>
-              <a:t> </a:t>
-            </a:r>
-            <a:r>
-              <a:rPr lang="de-DE" sz="2800" dirty="0" err="1">
-                <a:solidFill>
-                  <a:srgbClr val="FF0000"/>
-                </a:solidFill>
-                <a:latin typeface="Bahnschrift" panose="020B0502040204020203" pitchFamily="34" charset="0"/>
-                <a:cs typeface="Aharoni" panose="02010803020104030203" pitchFamily="2" charset="-79"/>
-              </a:rPr>
-              <a:t>board</a:t>
-            </a:r>
-            <a:r>
-              <a:rPr lang="de-DE" sz="2800" dirty="0">
-                <a:solidFill>
-                  <a:srgbClr val="FF0000"/>
-                </a:solidFill>
-                <a:latin typeface="Bahnschrift" panose="020B0502040204020203" pitchFamily="34" charset="0"/>
-                <a:cs typeface="Aharoni" panose="02010803020104030203" pitchFamily="2" charset="-79"/>
-              </a:rPr>
-              <a:t> </a:t>
-            </a:r>
-            <a:r>
-              <a:rPr lang="de-DE" sz="2800" dirty="0" err="1">
-                <a:solidFill>
-                  <a:srgbClr val="FF0000"/>
-                </a:solidFill>
-                <a:latin typeface="Bahnschrift" panose="020B0502040204020203" pitchFamily="34" charset="0"/>
-                <a:cs typeface="Aharoni" panose="02010803020104030203" pitchFamily="2" charset="-79"/>
-              </a:rPr>
-              <a:t>of</a:t>
-            </a:r>
-            <a:r>
-              <a:rPr lang="de-DE" sz="2800" dirty="0">
-                <a:solidFill>
-                  <a:srgbClr val="FF0000"/>
-                </a:solidFill>
-                <a:latin typeface="Bahnschrift" panose="020B0502040204020203" pitchFamily="34" charset="0"/>
-                <a:cs typeface="Aharoni" panose="02010803020104030203" pitchFamily="2" charset="-79"/>
-              </a:rPr>
-              <a:t> </a:t>
-            </a:r>
-            <a:r>
-              <a:rPr lang="de-DE" sz="2800" dirty="0" err="1">
-                <a:solidFill>
-                  <a:srgbClr val="FF0000"/>
-                </a:solidFill>
-                <a:latin typeface="Bahnschrift" panose="020B0502040204020203" pitchFamily="34" charset="0"/>
-                <a:cs typeface="Aharoni" panose="02010803020104030203" pitchFamily="2" charset="-79"/>
-              </a:rPr>
-              <a:t>directors</a:t>
-            </a:r>
-            <a:r>
-              <a:rPr lang="de-DE" sz="2800" dirty="0">
-                <a:solidFill>
-                  <a:srgbClr val="FF0000"/>
-                </a:solidFill>
-                <a:latin typeface="Bahnschrift" panose="020B0502040204020203" pitchFamily="34" charset="0"/>
-                <a:cs typeface="Aharoni" panose="02010803020104030203" pitchFamily="2" charset="-79"/>
-              </a:rPr>
-              <a:t>.</a:t>
+              <a:t>!</a:t>
             </a:r>
           </a:p>
           <a:p>
@@ -7889,6 +7706,16 @@
           <a:p>
             <a:pPr algn="ctr"/>
             <a:r>
+              <a:rPr lang="de-DE" sz="2400" dirty="0" err="1">
+                <a:solidFill>
+                  <a:srgbClr val="FF0000"/>
+                </a:solidFill>
+                <a:latin typeface="Bahnschrift" panose="020B0502040204020203" pitchFamily="34" charset="0"/>
+                <a:cs typeface="Aharoni" panose="02010803020104030203" pitchFamily="2" charset="-79"/>
+              </a:rPr>
+              <a:t>You</a:t>
+            </a:r>
+            <a:r>
               <a:rPr lang="de-DE" sz="2400" dirty="0">
                 <a:solidFill>
                   <a:srgbClr val="FF0000"/>
@@ -7896,7 +7723,7 @@
                 <a:latin typeface="Bahnschrift" panose="020B0502040204020203" pitchFamily="34" charset="0"/>
                 <a:cs typeface="Aharoni" panose="02010803020104030203" pitchFamily="2" charset="-79"/>
               </a:rPr>
-              <a:t>Pay </a:t>
+              <a:t> </a:t>
             </a:r>
             <a:r>
               <a:rPr lang="de-DE" sz="2400" dirty="0" err="1">
@@ -7906,7 +7733,7 @@
                 <a:latin typeface="Bahnschrift" panose="020B0502040204020203" pitchFamily="34" charset="0"/>
                 <a:cs typeface="Aharoni" panose="02010803020104030203" pitchFamily="2" charset="-79"/>
               </a:rPr>
-              <a:t>every</a:t>
+              <a:t>receive</a:t>
             </a:r>
             <a:r>
               <a:rPr lang="de-DE" sz="2400" dirty="0">
@@ -7916,27 +7743,7 @@
                 <a:latin typeface="Bahnschrift" panose="020B0502040204020203" pitchFamily="34" charset="0"/>
                 <a:cs typeface="Aharoni" panose="02010803020104030203" pitchFamily="2" charset="-79"/>
               </a:rPr>
-              <a:t> </a:t>
-            </a:r>
-            <a:r>
-              <a:rPr lang="de-DE" sz="2400" dirty="0" err="1">
-                <a:solidFill>
-                  <a:srgbClr val="FF0000"/>
-                </a:solidFill>
-                <a:latin typeface="Bahnschrift" panose="020B0502040204020203" pitchFamily="34" charset="0"/>
-                <a:cs typeface="Aharoni" panose="02010803020104030203" pitchFamily="2" charset="-79"/>
-              </a:rPr>
-              <a:t>player</a:t>
-            </a:r>
-            <a:r>
-              <a:rPr lang="de-DE" sz="2400" dirty="0">
-                <a:solidFill>
-                  <a:srgbClr val="FF0000"/>
-                </a:solidFill>
-                <a:latin typeface="Bahnschrift" panose="020B0502040204020203" pitchFamily="34" charset="0"/>
-                <a:cs typeface="Aharoni" panose="02010803020104030203" pitchFamily="2" charset="-79"/>
-              </a:rPr>
-              <a:t> 50€$</a:t>
+              <a:t> 150€$</a:t>
             </a:r>
           </a:p>
         </p:txBody>
@@ -7944,7 +7751,7 @@
     </p:spTree>
     <p:extLst>
       <p:ext uri="{BB962C8B-B14F-4D97-AF65-F5344CB8AC3E}">
-        <p14:creationId xmlns:p14="http://schemas.microsoft.com/office/powerpoint/2010/main" val="2087869271"/>
+        <p14:creationId xmlns:p14="http://schemas.microsoft.com/office/powerpoint/2010/main" val="3789431785"/>
       </p:ext>
     </p:extLst>
   </p:cSld>
@@ -8091,7 +7898,7 @@
         <p:spPr>
           <a:xfrm>
             <a:off x="2312751" y="2937751"/>
-            <a:ext cx="7566497" cy="1446550"/>
+            <a:ext cx="7566497" cy="1877437"/>
           </a:xfrm>
           <a:prstGeom prst="rect">
             <a:avLst/>
@@ -8106,6 +7913,16 @@
           <a:p>
             <a:pPr algn="ctr"/>
             <a:r>
+              <a:rPr lang="de-DE" sz="2800" dirty="0" err="1">
+                <a:solidFill>
+                  <a:srgbClr val="FF0000"/>
+                </a:solidFill>
+                <a:latin typeface="Bahnschrift" panose="020B0502040204020203" pitchFamily="34" charset="0"/>
+                <a:cs typeface="Aharoni" panose="02010803020104030203" pitchFamily="2" charset="-79"/>
+              </a:rPr>
+              <a:t>You</a:t>
+            </a:r>
+            <a:r>
               <a:rPr lang="de-DE" sz="2800" dirty="0">
                 <a:solidFill>
                   <a:srgbClr val="FF0000"/>
@@ -8113,7 +7930,7 @@
                 <a:latin typeface="Bahnschrift" panose="020B0502040204020203" pitchFamily="34" charset="0"/>
                 <a:cs typeface="Aharoni" panose="02010803020104030203" pitchFamily="2" charset="-79"/>
               </a:rPr>
-              <a:t>Move </a:t>
+              <a:t> </a:t>
             </a:r>
             <a:r>
               <a:rPr lang="de-DE" sz="2800" dirty="0" err="1">
@@ -8123,7 +7940,7 @@
                 <a:latin typeface="Bahnschrift" panose="020B0502040204020203" pitchFamily="34" charset="0"/>
                 <a:cs typeface="Aharoni" panose="02010803020104030203" pitchFamily="2" charset="-79"/>
               </a:rPr>
-              <a:t>forward</a:t>
+              <a:t>bribed</a:t>
             </a:r>
             <a:r>
               <a:rPr lang="de-DE" sz="2800" dirty="0">
@@ -8143,7 +7960,7 @@
                 <a:latin typeface="Bahnschrift" panose="020B0502040204020203" pitchFamily="34" charset="0"/>
                 <a:cs typeface="Aharoni" panose="02010803020104030203" pitchFamily="2" charset="-79"/>
               </a:rPr>
-              <a:t>until</a:t>
+              <a:t>the</a:t>
             </a:r>
             <a:r>
               <a:rPr lang="de-DE" sz="2800" dirty="0">
@@ -8163,6 +7980,126 @@
                 <a:latin typeface="Bahnschrift" panose="020B0502040204020203" pitchFamily="34" charset="0"/>
                 <a:cs typeface="Aharoni" panose="02010803020104030203" pitchFamily="2" charset="-79"/>
               </a:rPr>
+              <a:t>other</a:t>
+            </a:r>
+            <a:r>
+              <a:rPr lang="de-DE" sz="2800" dirty="0">
+                <a:solidFill>
+                  <a:srgbClr val="FF0000"/>
+                </a:solidFill>
+                <a:latin typeface="Bahnschrift" panose="020B0502040204020203" pitchFamily="34" charset="0"/>
+                <a:cs typeface="Aharoni" panose="02010803020104030203" pitchFamily="2" charset="-79"/>
+              </a:rPr>
+              <a:t> </a:t>
+            </a:r>
+            <a:r>
+              <a:rPr lang="de-DE" sz="2800" dirty="0" err="1">
+                <a:solidFill>
+                  <a:srgbClr val="FF0000"/>
+                </a:solidFill>
+                <a:latin typeface="Bahnschrift" panose="020B0502040204020203" pitchFamily="34" charset="0"/>
+                <a:cs typeface="Aharoni" panose="02010803020104030203" pitchFamily="2" charset="-79"/>
+              </a:rPr>
+              <a:t>players</a:t>
+            </a:r>
+            <a:r>
+              <a:rPr lang="de-DE" sz="2800" dirty="0">
+                <a:solidFill>
+                  <a:srgbClr val="FF0000"/>
+                </a:solidFill>
+                <a:latin typeface="Bahnschrift" panose="020B0502040204020203" pitchFamily="34" charset="0"/>
+                <a:cs typeface="Aharoni" panose="02010803020104030203" pitchFamily="2" charset="-79"/>
+              </a:rPr>
+              <a:t> </a:t>
+            </a:r>
+            <a:r>
+              <a:rPr lang="de-DE" sz="2800" dirty="0" err="1">
+                <a:solidFill>
+                  <a:srgbClr val="FF0000"/>
+                </a:solidFill>
+                <a:latin typeface="Bahnschrift" panose="020B0502040204020203" pitchFamily="34" charset="0"/>
+                <a:cs typeface="Aharoni" panose="02010803020104030203" pitchFamily="2" charset="-79"/>
+              </a:rPr>
+              <a:t>to</a:t>
+            </a:r>
+            <a:r>
+              <a:rPr lang="de-DE" sz="2800" dirty="0">
+                <a:solidFill>
+                  <a:srgbClr val="FF0000"/>
+                </a:solidFill>
+                <a:latin typeface="Bahnschrift" panose="020B0502040204020203" pitchFamily="34" charset="0"/>
+                <a:cs typeface="Aharoni" panose="02010803020104030203" pitchFamily="2" charset="-79"/>
+              </a:rPr>
+              <a:t> </a:t>
+            </a:r>
+            <a:r>
+              <a:rPr lang="de-DE" sz="2800" dirty="0" err="1">
+                <a:solidFill>
+                  <a:srgbClr val="FF0000"/>
+                </a:solidFill>
+                <a:latin typeface="Bahnschrift" panose="020B0502040204020203" pitchFamily="34" charset="0"/>
+                <a:cs typeface="Aharoni" panose="02010803020104030203" pitchFamily="2" charset="-79"/>
+              </a:rPr>
+              <a:t>become</a:t>
+            </a:r>
+            <a:r>
+              <a:rPr lang="de-DE" sz="2800" dirty="0">
+                <a:solidFill>
+                  <a:srgbClr val="FF0000"/>
+                </a:solidFill>
+                <a:latin typeface="Bahnschrift" panose="020B0502040204020203" pitchFamily="34" charset="0"/>
+                <a:cs typeface="Aharoni" panose="02010803020104030203" pitchFamily="2" charset="-79"/>
+              </a:rPr>
+              <a:t> </a:t>
+            </a:r>
+            <a:r>
+              <a:rPr lang="de-DE" sz="2800" dirty="0" err="1">
+                <a:solidFill>
+                  <a:srgbClr val="FF0000"/>
+                </a:solidFill>
+                <a:latin typeface="Bahnschrift" panose="020B0502040204020203" pitchFamily="34" charset="0"/>
+                <a:cs typeface="Aharoni" panose="02010803020104030203" pitchFamily="2" charset="-79"/>
+              </a:rPr>
+              <a:t>part</a:t>
+            </a:r>
+            <a:r>
+              <a:rPr lang="de-DE" sz="2800" dirty="0">
+                <a:solidFill>
+                  <a:srgbClr val="FF0000"/>
+                </a:solidFill>
+                <a:latin typeface="Bahnschrift" panose="020B0502040204020203" pitchFamily="34" charset="0"/>
+                <a:cs typeface="Aharoni" panose="02010803020104030203" pitchFamily="2" charset="-79"/>
+              </a:rPr>
+              <a:t> </a:t>
+            </a:r>
+            <a:r>
+              <a:rPr lang="de-DE" sz="2800" dirty="0" err="1">
+                <a:solidFill>
+                  <a:srgbClr val="FF0000"/>
+                </a:solidFill>
+                <a:latin typeface="Bahnschrift" panose="020B0502040204020203" pitchFamily="34" charset="0"/>
+                <a:cs typeface="Aharoni" panose="02010803020104030203" pitchFamily="2" charset="-79"/>
+              </a:rPr>
+              <a:t>of</a:t>
+            </a:r>
+            <a:r>
+              <a:rPr lang="de-DE" sz="2800" dirty="0">
+                <a:solidFill>
+                  <a:srgbClr val="FF0000"/>
+                </a:solidFill>
+                <a:latin typeface="Bahnschrift" panose="020B0502040204020203" pitchFamily="34" charset="0"/>
+                <a:cs typeface="Aharoni" panose="02010803020104030203" pitchFamily="2" charset="-79"/>
+              </a:rPr>
+              <a:t> </a:t>
+            </a:r>
+            <a:r>
+              <a:rPr lang="de-DE" sz="2800" dirty="0" err="1">
+                <a:solidFill>
+                  <a:srgbClr val="FF0000"/>
+                </a:solidFill>
+                <a:latin typeface="Bahnschrift" panose="020B0502040204020203" pitchFamily="34" charset="0"/>
+                <a:cs typeface="Aharoni" panose="02010803020104030203" pitchFamily="2" charset="-79"/>
+              </a:rPr>
               <a:t>the</a:t>
             </a:r>
             <a:r>
@@ -8176,22 +8113,65 @@
               <a:t> </a:t>
             </a:r>
             <a:r>
-              <a:rPr lang="de-DE" sz="2800" i="1" dirty="0">
-                <a:solidFill>
-                  <a:srgbClr val="FF0000"/>
-                </a:solidFill>
-                <a:latin typeface="Bahnschrift" panose="020B0502040204020203" pitchFamily="34" charset="0"/>
-                <a:cs typeface="Aharoni" panose="02010803020104030203" pitchFamily="2" charset="-79"/>
-              </a:rPr>
-              <a:t>Opernplatz.</a:t>
-            </a:r>
-            <a:endParaRPr lang="de-DE" sz="2800" dirty="0">
-              <a:solidFill>
-                <a:srgbClr val="FF0000"/>
-              </a:solidFill>
-              <a:latin typeface="Bahnschrift" panose="020B0502040204020203" pitchFamily="34" charset="0"/>
-              <a:cs typeface="Aharoni" panose="02010803020104030203" pitchFamily="2" charset="-79"/>
-            </a:endParaRPr>
+              <a:rPr lang="de-DE" sz="2800" dirty="0" err="1">
+                <a:solidFill>
+                  <a:srgbClr val="FF0000"/>
+                </a:solidFill>
+                <a:latin typeface="Bahnschrift" panose="020B0502040204020203" pitchFamily="34" charset="0"/>
+                <a:cs typeface="Aharoni" panose="02010803020104030203" pitchFamily="2" charset="-79"/>
+              </a:rPr>
+              <a:t>board</a:t>
+            </a:r>
+            <a:r>
+              <a:rPr lang="de-DE" sz="2800" dirty="0">
+                <a:solidFill>
+                  <a:srgbClr val="FF0000"/>
+                </a:solidFill>
+                <a:latin typeface="Bahnschrift" panose="020B0502040204020203" pitchFamily="34" charset="0"/>
+                <a:cs typeface="Aharoni" panose="02010803020104030203" pitchFamily="2" charset="-79"/>
+              </a:rPr>
+              <a:t> </a:t>
+            </a:r>
+            <a:r>
+              <a:rPr lang="de-DE" sz="2800" dirty="0" err="1">
+                <a:solidFill>
+                  <a:srgbClr val="FF0000"/>
+                </a:solidFill>
+                <a:latin typeface="Bahnschrift" panose="020B0502040204020203" pitchFamily="34" charset="0"/>
+                <a:cs typeface="Aharoni" panose="02010803020104030203" pitchFamily="2" charset="-79"/>
+              </a:rPr>
+              <a:t>of</a:t>
+            </a:r>
+            <a:r>
+              <a:rPr lang="de-DE" sz="2800" dirty="0">
+                <a:solidFill>
+                  <a:srgbClr val="FF0000"/>
+                </a:solidFill>
+                <a:latin typeface="Bahnschrift" panose="020B0502040204020203" pitchFamily="34" charset="0"/>
+                <a:cs typeface="Aharoni" panose="02010803020104030203" pitchFamily="2" charset="-79"/>
+              </a:rPr>
+              <a:t> </a:t>
+            </a:r>
+            <a:r>
+              <a:rPr lang="de-DE" sz="2800" dirty="0" err="1">
+                <a:solidFill>
+                  <a:srgbClr val="FF0000"/>
+                </a:solidFill>
+                <a:latin typeface="Bahnschrift" panose="020B0502040204020203" pitchFamily="34" charset="0"/>
+                <a:cs typeface="Aharoni" panose="02010803020104030203" pitchFamily="2" charset="-79"/>
+              </a:rPr>
+              <a:t>directors</a:t>
+            </a:r>
+            <a:r>
+              <a:rPr lang="de-DE" sz="2800" dirty="0">
+                <a:solidFill>
+                  <a:srgbClr val="FF0000"/>
+                </a:solidFill>
+                <a:latin typeface="Bahnschrift" panose="020B0502040204020203" pitchFamily="34" charset="0"/>
+                <a:cs typeface="Aharoni" panose="02010803020104030203" pitchFamily="2" charset="-79"/>
+              </a:rPr>
+              <a:t>.</a:t>
+            </a:r>
           </a:p>
           <a:p>
             <a:pPr algn="ctr"/>
@@ -8206,6 +8186,16 @@
           <a:p>
             <a:pPr algn="ctr"/>
             <a:r>
+              <a:rPr lang="de-DE" sz="2400" dirty="0">
+                <a:solidFill>
+                  <a:srgbClr val="FF0000"/>
+                </a:solidFill>
+                <a:latin typeface="Bahnschrift" panose="020B0502040204020203" pitchFamily="34" charset="0"/>
+                <a:cs typeface="Aharoni" panose="02010803020104030203" pitchFamily="2" charset="-79"/>
+              </a:rPr>
+              <a:t>Pay </a:t>
+            </a:r>
+            <a:r>
               <a:rPr lang="de-DE" sz="2400" dirty="0" err="1">
                 <a:solidFill>
                   <a:srgbClr val="FF0000"/>
@@ -8213,7 +8203,7 @@
                 <a:latin typeface="Bahnschrift" panose="020B0502040204020203" pitchFamily="34" charset="0"/>
                 <a:cs typeface="Aharoni" panose="02010803020104030203" pitchFamily="2" charset="-79"/>
               </a:rPr>
-              <a:t>When</a:t>
+              <a:t>every</a:t>
             </a:r>
             <a:r>
               <a:rPr lang="de-DE" sz="2400" dirty="0">
@@ -8233,7 +8223,7 @@
                 <a:latin typeface="Bahnschrift" panose="020B0502040204020203" pitchFamily="34" charset="0"/>
                 <a:cs typeface="Aharoni" panose="02010803020104030203" pitchFamily="2" charset="-79"/>
               </a:rPr>
-              <a:t>passing</a:t>
+              <a:t>player</a:t>
             </a:r>
             <a:r>
               <a:rPr lang="de-DE" sz="2400" dirty="0">
@@ -8243,47 +8233,7 @@
                 <a:latin typeface="Bahnschrift" panose="020B0502040204020203" pitchFamily="34" charset="0"/>
                 <a:cs typeface="Aharoni" panose="02010803020104030203" pitchFamily="2" charset="-79"/>
               </a:rPr>
-              <a:t> GO </a:t>
-            </a:r>
-            <a:r>
-              <a:rPr lang="de-DE" sz="2400" dirty="0" err="1">
-                <a:solidFill>
-                  <a:srgbClr val="FF0000"/>
-                </a:solidFill>
-                <a:latin typeface="Bahnschrift" panose="020B0502040204020203" pitchFamily="34" charset="0"/>
-                <a:cs typeface="Aharoni" panose="02010803020104030203" pitchFamily="2" charset="-79"/>
-              </a:rPr>
-              <a:t>you</a:t>
-            </a:r>
-            <a:r>
-              <a:rPr lang="de-DE" sz="2400" dirty="0">
-                <a:solidFill>
-                  <a:srgbClr val="FF0000"/>
-                </a:solidFill>
-                <a:latin typeface="Bahnschrift" panose="020B0502040204020203" pitchFamily="34" charset="0"/>
-                <a:cs typeface="Aharoni" panose="02010803020104030203" pitchFamily="2" charset="-79"/>
-              </a:rPr>
-              <a:t> will </a:t>
-            </a:r>
-            <a:r>
-              <a:rPr lang="de-DE" sz="2400" dirty="0" err="1">
-                <a:solidFill>
-                  <a:srgbClr val="FF0000"/>
-                </a:solidFill>
-                <a:latin typeface="Bahnschrift" panose="020B0502040204020203" pitchFamily="34" charset="0"/>
-                <a:cs typeface="Aharoni" panose="02010803020104030203" pitchFamily="2" charset="-79"/>
-              </a:rPr>
-              <a:t>receive</a:t>
-            </a:r>
-            <a:r>
-              <a:rPr lang="de-DE" sz="2400" dirty="0">
-                <a:solidFill>
-                  <a:srgbClr val="FF0000"/>
-                </a:solidFill>
-                <a:latin typeface="Bahnschrift" panose="020B0502040204020203" pitchFamily="34" charset="0"/>
-                <a:cs typeface="Aharoni" panose="02010803020104030203" pitchFamily="2" charset="-79"/>
-              </a:rPr>
-              <a:t> 200€$.</a:t>
+              <a:t> 50€$</a:t>
             </a:r>
           </a:p>
         </p:txBody>
@@ -8291,7 +8241,7 @@
     </p:spTree>
     <p:extLst>
       <p:ext uri="{BB962C8B-B14F-4D97-AF65-F5344CB8AC3E}">
-        <p14:creationId xmlns:p14="http://schemas.microsoft.com/office/powerpoint/2010/main" val="2115344453"/>
+        <p14:creationId xmlns:p14="http://schemas.microsoft.com/office/powerpoint/2010/main" val="2087869271"/>
       </p:ext>
     </p:extLst>
   </p:cSld>
@@ -8453,6 +8403,16 @@
           <a:p>
             <a:pPr algn="ctr"/>
             <a:r>
+              <a:rPr lang="de-DE" sz="2800" dirty="0">
+                <a:solidFill>
+                  <a:srgbClr val="FF0000"/>
+                </a:solidFill>
+                <a:latin typeface="Bahnschrift" panose="020B0502040204020203" pitchFamily="34" charset="0"/>
+                <a:cs typeface="Aharoni" panose="02010803020104030203" pitchFamily="2" charset="-79"/>
+              </a:rPr>
+              <a:t>Move </a:t>
+            </a:r>
+            <a:r>
               <a:rPr lang="de-DE" sz="2800" dirty="0" err="1">
                 <a:solidFill>
                   <a:srgbClr val="FF0000"/>
@@ -8460,7 +8420,7 @@
                 <a:latin typeface="Bahnschrift" panose="020B0502040204020203" pitchFamily="34" charset="0"/>
                 <a:cs typeface="Aharoni" panose="02010803020104030203" pitchFamily="2" charset="-79"/>
               </a:rPr>
-              <a:t>You</a:t>
+              <a:t>forward</a:t>
             </a:r>
             <a:r>
               <a:rPr lang="de-DE" sz="2800" dirty="0">
@@ -8480,7 +8440,7 @@
                 <a:latin typeface="Bahnschrift" panose="020B0502040204020203" pitchFamily="34" charset="0"/>
                 <a:cs typeface="Aharoni" panose="02010803020104030203" pitchFamily="2" charset="-79"/>
               </a:rPr>
-              <a:t>won</a:t>
+              <a:t>until</a:t>
             </a:r>
             <a:r>
               <a:rPr lang="de-DE" sz="2800" dirty="0">
@@ -8490,7 +8450,7 @@
                 <a:latin typeface="Bahnschrift" panose="020B0502040204020203" pitchFamily="34" charset="0"/>
                 <a:cs typeface="Aharoni" panose="02010803020104030203" pitchFamily="2" charset="-79"/>
               </a:rPr>
-              <a:t> in a </a:t>
+              <a:t> </a:t>
             </a:r>
             <a:r>
               <a:rPr lang="de-DE" sz="2800" dirty="0" err="1">
@@ -8500,7 +8460,7 @@
                 <a:latin typeface="Bahnschrift" panose="020B0502040204020203" pitchFamily="34" charset="0"/>
                 <a:cs typeface="Aharoni" panose="02010803020104030203" pitchFamily="2" charset="-79"/>
               </a:rPr>
-              <a:t>crossword</a:t>
+              <a:t>the</a:t>
             </a:r>
             <a:r>
               <a:rPr lang="de-DE" sz="2800" dirty="0">
@@ -8513,25 +8473,22 @@
               <a:t> </a:t>
             </a:r>
             <a:r>
-              <a:rPr lang="de-DE" sz="2800" dirty="0" err="1">
-                <a:solidFill>
-                  <a:srgbClr val="FF0000"/>
-                </a:solidFill>
-                <a:latin typeface="Bahnschrift" panose="020B0502040204020203" pitchFamily="34" charset="0"/>
-                <a:cs typeface="Aharoni" panose="02010803020104030203" pitchFamily="2" charset="-79"/>
-              </a:rPr>
-              <a:t>contest</a:t>
-            </a:r>
-            <a:r>
-              <a:rPr lang="de-DE" sz="2800" dirty="0">
-                <a:solidFill>
-                  <a:srgbClr val="FF0000"/>
-                </a:solidFill>
-                <a:latin typeface="Bahnschrift" panose="020B0502040204020203" pitchFamily="34" charset="0"/>
-                <a:cs typeface="Aharoni" panose="02010803020104030203" pitchFamily="2" charset="-79"/>
-              </a:rPr>
-              <a:t>!</a:t>
-            </a:r>
+              <a:rPr lang="de-DE" sz="2800" i="1" dirty="0">
+                <a:solidFill>
+                  <a:srgbClr val="FF0000"/>
+                </a:solidFill>
+                <a:latin typeface="Bahnschrift" panose="020B0502040204020203" pitchFamily="34" charset="0"/>
+                <a:cs typeface="Aharoni" panose="02010803020104030203" pitchFamily="2" charset="-79"/>
+              </a:rPr>
+              <a:t>Opernplatz.</a:t>
+            </a:r>
+            <a:endParaRPr lang="de-DE" sz="2800" dirty="0">
+              <a:solidFill>
+                <a:srgbClr val="FF0000"/>
+              </a:solidFill>
+              <a:latin typeface="Bahnschrift" panose="020B0502040204020203" pitchFamily="34" charset="0"/>
+              <a:cs typeface="Aharoni" panose="02010803020104030203" pitchFamily="2" charset="-79"/>
+            </a:endParaRPr>
           </a:p>
           <a:p>
             <a:pPr algn="ctr"/>
@@ -8553,7 +8510,7 @@
                 <a:latin typeface="Bahnschrift" panose="020B0502040204020203" pitchFamily="34" charset="0"/>
                 <a:cs typeface="Aharoni" panose="02010803020104030203" pitchFamily="2" charset="-79"/>
               </a:rPr>
-              <a:t>You</a:t>
+              <a:t>When</a:t>
             </a:r>
             <a:r>
               <a:rPr lang="de-DE" sz="2400" dirty="0">
@@ -8573,6 +8530,46 @@
                 <a:latin typeface="Bahnschrift" panose="020B0502040204020203" pitchFamily="34" charset="0"/>
                 <a:cs typeface="Aharoni" panose="02010803020104030203" pitchFamily="2" charset="-79"/>
               </a:rPr>
+              <a:t>passing</a:t>
+            </a:r>
+            <a:r>
+              <a:rPr lang="de-DE" sz="2400" dirty="0">
+                <a:solidFill>
+                  <a:srgbClr val="FF0000"/>
+                </a:solidFill>
+                <a:latin typeface="Bahnschrift" panose="020B0502040204020203" pitchFamily="34" charset="0"/>
+                <a:cs typeface="Aharoni" panose="02010803020104030203" pitchFamily="2" charset="-79"/>
+              </a:rPr>
+              <a:t> GO </a:t>
+            </a:r>
+            <a:r>
+              <a:rPr lang="de-DE" sz="2400" dirty="0" err="1">
+                <a:solidFill>
+                  <a:srgbClr val="FF0000"/>
+                </a:solidFill>
+                <a:latin typeface="Bahnschrift" panose="020B0502040204020203" pitchFamily="34" charset="0"/>
+                <a:cs typeface="Aharoni" panose="02010803020104030203" pitchFamily="2" charset="-79"/>
+              </a:rPr>
+              <a:t>you</a:t>
+            </a:r>
+            <a:r>
+              <a:rPr lang="de-DE" sz="2400" dirty="0">
+                <a:solidFill>
+                  <a:srgbClr val="FF0000"/>
+                </a:solidFill>
+                <a:latin typeface="Bahnschrift" panose="020B0502040204020203" pitchFamily="34" charset="0"/>
+                <a:cs typeface="Aharoni" panose="02010803020104030203" pitchFamily="2" charset="-79"/>
+              </a:rPr>
+              <a:t> will </a:t>
+            </a:r>
+            <a:r>
+              <a:rPr lang="de-DE" sz="2400" dirty="0" err="1">
+                <a:solidFill>
+                  <a:srgbClr val="FF0000"/>
+                </a:solidFill>
+                <a:latin typeface="Bahnschrift" panose="020B0502040204020203" pitchFamily="34" charset="0"/>
+                <a:cs typeface="Aharoni" panose="02010803020104030203" pitchFamily="2" charset="-79"/>
+              </a:rPr>
               <a:t>receive</a:t>
             </a:r>
             <a:r>
@@ -8583,7 +8580,7 @@
                 <a:latin typeface="Bahnschrift" panose="020B0502040204020203" pitchFamily="34" charset="0"/>
                 <a:cs typeface="Aharoni" panose="02010803020104030203" pitchFamily="2" charset="-79"/>
               </a:rPr>
-              <a:t> 100€$.</a:t>
+              <a:t> 200€$.</a:t>
             </a:r>
           </a:p>
         </p:txBody>
@@ -8591,7 +8588,7 @@
     </p:spTree>
     <p:extLst>
       <p:ext uri="{BB962C8B-B14F-4D97-AF65-F5344CB8AC3E}">
-        <p14:creationId xmlns:p14="http://schemas.microsoft.com/office/powerpoint/2010/main" val="4074890750"/>
+        <p14:creationId xmlns:p14="http://schemas.microsoft.com/office/powerpoint/2010/main" val="2115344453"/>
       </p:ext>
     </p:extLst>
   </p:cSld>
@@ -8753,6 +8750,16 @@
           <a:p>
             <a:pPr algn="ctr"/>
             <a:r>
+              <a:rPr lang="de-DE" sz="2800" dirty="0" err="1">
+                <a:solidFill>
+                  <a:srgbClr val="FF0000"/>
+                </a:solidFill>
+                <a:latin typeface="Bahnschrift" panose="020B0502040204020203" pitchFamily="34" charset="0"/>
+                <a:cs typeface="Aharoni" panose="02010803020104030203" pitchFamily="2" charset="-79"/>
+              </a:rPr>
+              <a:t>You</a:t>
+            </a:r>
+            <a:r>
               <a:rPr lang="de-DE" sz="2800" dirty="0">
                 <a:solidFill>
                   <a:srgbClr val="FF0000"/>
@@ -8760,7 +8767,7 @@
                 <a:latin typeface="Bahnschrift" panose="020B0502040204020203" pitchFamily="34" charset="0"/>
                 <a:cs typeface="Aharoni" panose="02010803020104030203" pitchFamily="2" charset="-79"/>
               </a:rPr>
-              <a:t>Move </a:t>
+              <a:t> </a:t>
             </a:r>
             <a:r>
               <a:rPr lang="de-DE" sz="2800" dirty="0" err="1">
@@ -8770,7 +8777,7 @@
                 <a:latin typeface="Bahnschrift" panose="020B0502040204020203" pitchFamily="34" charset="0"/>
                 <a:cs typeface="Aharoni" panose="02010803020104030203" pitchFamily="2" charset="-79"/>
               </a:rPr>
-              <a:t>forward</a:t>
+              <a:t>won</a:t>
             </a:r>
             <a:r>
               <a:rPr lang="de-DE" sz="2800" dirty="0">
@@ -8780,6 +8787,26 @@
                 <a:latin typeface="Bahnschrift" panose="020B0502040204020203" pitchFamily="34" charset="0"/>
                 <a:cs typeface="Aharoni" panose="02010803020104030203" pitchFamily="2" charset="-79"/>
               </a:rPr>
+              <a:t> in a </a:t>
+            </a:r>
+            <a:r>
+              <a:rPr lang="de-DE" sz="2800" dirty="0" err="1">
+                <a:solidFill>
+                  <a:srgbClr val="FF0000"/>
+                </a:solidFill>
+                <a:latin typeface="Bahnschrift" panose="020B0502040204020203" pitchFamily="34" charset="0"/>
+                <a:cs typeface="Aharoni" panose="02010803020104030203" pitchFamily="2" charset="-79"/>
+              </a:rPr>
+              <a:t>crossword</a:t>
+            </a:r>
+            <a:r>
+              <a:rPr lang="de-DE" sz="2800" dirty="0">
+                <a:solidFill>
+                  <a:srgbClr val="FF0000"/>
+                </a:solidFill>
+                <a:latin typeface="Bahnschrift" panose="020B0502040204020203" pitchFamily="34" charset="0"/>
+                <a:cs typeface="Aharoni" panose="02010803020104030203" pitchFamily="2" charset="-79"/>
+              </a:rPr>
               <a:t> </a:t>
             </a:r>
             <a:r>
@@ -8790,7 +8817,7 @@
                 <a:latin typeface="Bahnschrift" panose="020B0502040204020203" pitchFamily="34" charset="0"/>
                 <a:cs typeface="Aharoni" panose="02010803020104030203" pitchFamily="2" charset="-79"/>
               </a:rPr>
-              <a:t>until</a:t>
+              <a:t>contest</a:t>
             </a:r>
             <a:r>
               <a:rPr lang="de-DE" sz="2800" dirty="0">
@@ -8800,37 +8827,7 @@
                 <a:latin typeface="Bahnschrift" panose="020B0502040204020203" pitchFamily="34" charset="0"/>
                 <a:cs typeface="Aharoni" panose="02010803020104030203" pitchFamily="2" charset="-79"/>
               </a:rPr>
-              <a:t> </a:t>
-            </a:r>
-            <a:r>
-              <a:rPr lang="de-DE" sz="2800" dirty="0" err="1">
-                <a:solidFill>
-                  <a:srgbClr val="FF0000"/>
-                </a:solidFill>
-                <a:latin typeface="Bahnschrift" panose="020B0502040204020203" pitchFamily="34" charset="0"/>
-                <a:cs typeface="Aharoni" panose="02010803020104030203" pitchFamily="2" charset="-79"/>
-              </a:rPr>
-              <a:t>the</a:t>
-            </a:r>
-            <a:r>
-              <a:rPr lang="de-DE" sz="2800" dirty="0">
-                <a:solidFill>
-                  <a:srgbClr val="FF0000"/>
-                </a:solidFill>
-                <a:latin typeface="Bahnschrift" panose="020B0502040204020203" pitchFamily="34" charset="0"/>
-                <a:cs typeface="Aharoni" panose="02010803020104030203" pitchFamily="2" charset="-79"/>
-              </a:rPr>
-              <a:t> </a:t>
-            </a:r>
-            <a:r>
-              <a:rPr lang="de-DE" sz="2800" i="1" dirty="0">
-                <a:solidFill>
-                  <a:srgbClr val="FF0000"/>
-                </a:solidFill>
-                <a:latin typeface="Bahnschrift" panose="020B0502040204020203" pitchFamily="34" charset="0"/>
-                <a:cs typeface="Aharoni" panose="02010803020104030203" pitchFamily="2" charset="-79"/>
-              </a:rPr>
-              <a:t>Schlossallee.</a:t>
+              <a:t>!</a:t>
             </a:r>
           </a:p>
           <a:p>
@@ -8845,20 +8842,53 @@
           </a:p>
           <a:p>
             <a:pPr algn="ctr"/>
-            <a:endParaRPr lang="de-DE" sz="2400" dirty="0">
-              <a:solidFill>
-                <a:srgbClr val="FF0000"/>
-              </a:solidFill>
-              <a:latin typeface="Bahnschrift" panose="020B0502040204020203" pitchFamily="34" charset="0"/>
-              <a:cs typeface="Aharoni" panose="02010803020104030203" pitchFamily="2" charset="-79"/>
-            </a:endParaRPr>
+            <a:r>
+              <a:rPr lang="de-DE" sz="2400" dirty="0" err="1">
+                <a:solidFill>
+                  <a:srgbClr val="FF0000"/>
+                </a:solidFill>
+                <a:latin typeface="Bahnschrift" panose="020B0502040204020203" pitchFamily="34" charset="0"/>
+                <a:cs typeface="Aharoni" panose="02010803020104030203" pitchFamily="2" charset="-79"/>
+              </a:rPr>
+              <a:t>You</a:t>
+            </a:r>
+            <a:r>
+              <a:rPr lang="de-DE" sz="2400" dirty="0">
+                <a:solidFill>
+                  <a:srgbClr val="FF0000"/>
+                </a:solidFill>
+                <a:latin typeface="Bahnschrift" panose="020B0502040204020203" pitchFamily="34" charset="0"/>
+                <a:cs typeface="Aharoni" panose="02010803020104030203" pitchFamily="2" charset="-79"/>
+              </a:rPr>
+              <a:t> </a:t>
+            </a:r>
+            <a:r>
+              <a:rPr lang="de-DE" sz="2400" dirty="0" err="1">
+                <a:solidFill>
+                  <a:srgbClr val="FF0000"/>
+                </a:solidFill>
+                <a:latin typeface="Bahnschrift" panose="020B0502040204020203" pitchFamily="34" charset="0"/>
+                <a:cs typeface="Aharoni" panose="02010803020104030203" pitchFamily="2" charset="-79"/>
+              </a:rPr>
+              <a:t>receive</a:t>
+            </a:r>
+            <a:r>
+              <a:rPr lang="de-DE" sz="2400" dirty="0">
+                <a:solidFill>
+                  <a:srgbClr val="FF0000"/>
+                </a:solidFill>
+                <a:latin typeface="Bahnschrift" panose="020B0502040204020203" pitchFamily="34" charset="0"/>
+                <a:cs typeface="Aharoni" panose="02010803020104030203" pitchFamily="2" charset="-79"/>
+              </a:rPr>
+              <a:t> 100€$.</a:t>
+            </a:r>
           </a:p>
         </p:txBody>
       </p:sp>
     </p:spTree>
     <p:extLst>
       <p:ext uri="{BB962C8B-B14F-4D97-AF65-F5344CB8AC3E}">
-        <p14:creationId xmlns:p14="http://schemas.microsoft.com/office/powerpoint/2010/main" val="290504147"/>
+        <p14:creationId xmlns:p14="http://schemas.microsoft.com/office/powerpoint/2010/main" val="4074890750"/>
       </p:ext>
     </p:extLst>
   </p:cSld>
@@ -9027,7 +9057,7 @@
                 <a:latin typeface="Bahnschrift" panose="020B0502040204020203" pitchFamily="34" charset="0"/>
                 <a:cs typeface="Aharoni" panose="02010803020104030203" pitchFamily="2" charset="-79"/>
               </a:rPr>
-              <a:t>Move 3 </a:t>
+              <a:t>Move </a:t>
             </a:r>
             <a:r>
               <a:rPr lang="de-DE" sz="2800" dirty="0" err="1">
@@ -9037,7 +9067,7 @@
                 <a:latin typeface="Bahnschrift" panose="020B0502040204020203" pitchFamily="34" charset="0"/>
                 <a:cs typeface="Aharoni" panose="02010803020104030203" pitchFamily="2" charset="-79"/>
               </a:rPr>
-              <a:t>fields</a:t>
+              <a:t>forward</a:t>
             </a:r>
             <a:r>
               <a:rPr lang="de-DE" sz="2800" dirty="0">
@@ -9047,7 +9077,57 @@
                 <a:latin typeface="Bahnschrift" panose="020B0502040204020203" pitchFamily="34" charset="0"/>
                 <a:cs typeface="Aharoni" panose="02010803020104030203" pitchFamily="2" charset="-79"/>
               </a:rPr>
-              <a:t> back.</a:t>
+              <a:t> </a:t>
+            </a:r>
+            <a:r>
+              <a:rPr lang="de-DE" sz="2800" dirty="0" err="1">
+                <a:solidFill>
+                  <a:srgbClr val="FF0000"/>
+                </a:solidFill>
+                <a:latin typeface="Bahnschrift" panose="020B0502040204020203" pitchFamily="34" charset="0"/>
+                <a:cs typeface="Aharoni" panose="02010803020104030203" pitchFamily="2" charset="-79"/>
+              </a:rPr>
+              <a:t>until</a:t>
+            </a:r>
+            <a:r>
+              <a:rPr lang="de-DE" sz="2800" dirty="0">
+                <a:solidFill>
+                  <a:srgbClr val="FF0000"/>
+                </a:solidFill>
+                <a:latin typeface="Bahnschrift" panose="020B0502040204020203" pitchFamily="34" charset="0"/>
+                <a:cs typeface="Aharoni" panose="02010803020104030203" pitchFamily="2" charset="-79"/>
+              </a:rPr>
+              <a:t> </a:t>
+            </a:r>
+            <a:r>
+              <a:rPr lang="de-DE" sz="2800" dirty="0" err="1">
+                <a:solidFill>
+                  <a:srgbClr val="FF0000"/>
+                </a:solidFill>
+                <a:latin typeface="Bahnschrift" panose="020B0502040204020203" pitchFamily="34" charset="0"/>
+                <a:cs typeface="Aharoni" panose="02010803020104030203" pitchFamily="2" charset="-79"/>
+              </a:rPr>
+              <a:t>the</a:t>
+            </a:r>
+            <a:r>
+              <a:rPr lang="de-DE" sz="2800" dirty="0">
+                <a:solidFill>
+                  <a:srgbClr val="FF0000"/>
+                </a:solidFill>
+                <a:latin typeface="Bahnschrift" panose="020B0502040204020203" pitchFamily="34" charset="0"/>
+                <a:cs typeface="Aharoni" panose="02010803020104030203" pitchFamily="2" charset="-79"/>
+              </a:rPr>
+              <a:t> </a:t>
+            </a:r>
+            <a:r>
+              <a:rPr lang="de-DE" sz="2800" i="1" dirty="0">
+                <a:solidFill>
+                  <a:srgbClr val="FF0000"/>
+                </a:solidFill>
+                <a:latin typeface="Bahnschrift" panose="020B0502040204020203" pitchFamily="34" charset="0"/>
+                <a:cs typeface="Aharoni" panose="02010803020104030203" pitchFamily="2" charset="-79"/>
+              </a:rPr>
+              <a:t>Schlossallee.</a:t>
             </a:r>
           </a:p>
           <a:p>
@@ -9075,7 +9155,7 @@
     </p:spTree>
     <p:extLst>
       <p:ext uri="{BB962C8B-B14F-4D97-AF65-F5344CB8AC3E}">
-        <p14:creationId xmlns:p14="http://schemas.microsoft.com/office/powerpoint/2010/main" val="3623564745"/>
+        <p14:creationId xmlns:p14="http://schemas.microsoft.com/office/powerpoint/2010/main" val="290504147"/>
       </p:ext>
     </p:extLst>
   </p:cSld>
@@ -9221,8 +9301,8 @@
         </p:nvSpPr>
         <p:spPr>
           <a:xfrm>
-            <a:off x="3532762" y="2869659"/>
-            <a:ext cx="5126476" cy="1508105"/>
+            <a:off x="2312751" y="2937751"/>
+            <a:ext cx="7566497" cy="1446550"/>
           </a:xfrm>
           <a:prstGeom prst="rect">
             <a:avLst/>
@@ -9237,6 +9317,16 @@
           <a:p>
             <a:pPr algn="ctr"/>
             <a:r>
+              <a:rPr lang="de-DE" sz="2800" dirty="0">
+                <a:solidFill>
+                  <a:srgbClr val="FF0000"/>
+                </a:solidFill>
+                <a:latin typeface="Bahnschrift" panose="020B0502040204020203" pitchFamily="34" charset="0"/>
+                <a:cs typeface="Aharoni" panose="02010803020104030203" pitchFamily="2" charset="-79"/>
+              </a:rPr>
+              <a:t>Move 3 </a:t>
+            </a:r>
+            <a:r>
               <a:rPr lang="de-DE" sz="2800" dirty="0" err="1">
                 <a:solidFill>
                   <a:srgbClr val="FF0000"/>
@@ -9244,7 +9334,7 @@
                 <a:latin typeface="Bahnschrift" panose="020B0502040204020203" pitchFamily="34" charset="0"/>
                 <a:cs typeface="Aharoni" panose="02010803020104030203" pitchFamily="2" charset="-79"/>
               </a:rPr>
-              <a:t>You‘re</a:t>
+              <a:t>fields</a:t>
             </a:r>
             <a:r>
               <a:rPr lang="de-DE" sz="2800" dirty="0">
@@ -9254,28 +9344,11 @@
                 <a:latin typeface="Bahnschrift" panose="020B0502040204020203" pitchFamily="34" charset="0"/>
                 <a:cs typeface="Aharoni" panose="02010803020104030203" pitchFamily="2" charset="-79"/>
               </a:rPr>
-              <a:t> </a:t>
-            </a:r>
-            <a:r>
-              <a:rPr lang="de-DE" sz="2800" dirty="0" err="1">
-                <a:solidFill>
-                  <a:srgbClr val="FF0000"/>
-                </a:solidFill>
-                <a:latin typeface="Bahnschrift" panose="020B0502040204020203" pitchFamily="34" charset="0"/>
-                <a:cs typeface="Aharoni" panose="02010803020104030203" pitchFamily="2" charset="-79"/>
-              </a:rPr>
-              <a:t>busted</a:t>
-            </a:r>
-            <a:r>
-              <a:rPr lang="de-DE" sz="2800" dirty="0">
-                <a:solidFill>
-                  <a:srgbClr val="FF0000"/>
-                </a:solidFill>
-                <a:latin typeface="Bahnschrift" panose="020B0502040204020203" pitchFamily="34" charset="0"/>
-                <a:cs typeface="Aharoni" panose="02010803020104030203" pitchFamily="2" charset="-79"/>
-              </a:rPr>
-              <a:t>!</a:t>
-            </a:r>
+              <a:t> back.</a:t>
+            </a:r>
+          </a:p>
+          <a:p>
+            <a:pPr algn="ctr"/>
             <a:endParaRPr lang="de-DE" sz="3600" dirty="0">
               <a:solidFill>
                 <a:srgbClr val="FF0000"/>
@@ -9286,7 +9359,7 @@
           </a:p>
           <a:p>
             <a:pPr algn="ctr"/>
-            <a:endParaRPr lang="de-DE" sz="2800" dirty="0">
+            <a:endParaRPr lang="de-DE" sz="2400" dirty="0">
               <a:solidFill>
                 <a:srgbClr val="FF0000"/>
               </a:solidFill>
@@ -9294,205 +9367,12 @@
               <a:cs typeface="Aharoni" panose="02010803020104030203" pitchFamily="2" charset="-79"/>
             </a:endParaRPr>
           </a:p>
-          <a:p>
-            <a:pPr algn="ctr"/>
-            <a:r>
-              <a:rPr lang="de-DE" dirty="0">
-                <a:solidFill>
-                  <a:srgbClr val="FF0000"/>
-                </a:solidFill>
-                <a:latin typeface="Bahnschrift" panose="020B0502040204020203" pitchFamily="34" charset="0"/>
-                <a:cs typeface="Aharoni" panose="02010803020104030203" pitchFamily="2" charset="-79"/>
-              </a:rPr>
-              <a:t>On </a:t>
-            </a:r>
-            <a:r>
-              <a:rPr lang="de-DE" dirty="0" err="1">
-                <a:solidFill>
-                  <a:srgbClr val="FF0000"/>
-                </a:solidFill>
-                <a:latin typeface="Bahnschrift" panose="020B0502040204020203" pitchFamily="34" charset="0"/>
-                <a:cs typeface="Aharoni" panose="02010803020104030203" pitchFamily="2" charset="-79"/>
-              </a:rPr>
-              <a:t>your</a:t>
-            </a:r>
-            <a:r>
-              <a:rPr lang="de-DE" dirty="0">
-                <a:solidFill>
-                  <a:srgbClr val="FF0000"/>
-                </a:solidFill>
-                <a:latin typeface="Bahnschrift" panose="020B0502040204020203" pitchFamily="34" charset="0"/>
-                <a:cs typeface="Aharoni" panose="02010803020104030203" pitchFamily="2" charset="-79"/>
-              </a:rPr>
-              <a:t> </a:t>
-            </a:r>
-            <a:r>
-              <a:rPr lang="de-DE" dirty="0" err="1">
-                <a:solidFill>
-                  <a:srgbClr val="FF0000"/>
-                </a:solidFill>
-                <a:latin typeface="Bahnschrift" panose="020B0502040204020203" pitchFamily="34" charset="0"/>
-                <a:cs typeface="Aharoni" panose="02010803020104030203" pitchFamily="2" charset="-79"/>
-              </a:rPr>
-              <a:t>way</a:t>
-            </a:r>
-            <a:r>
-              <a:rPr lang="de-DE" dirty="0">
-                <a:solidFill>
-                  <a:srgbClr val="FF0000"/>
-                </a:solidFill>
-                <a:latin typeface="Bahnschrift" panose="020B0502040204020203" pitchFamily="34" charset="0"/>
-                <a:cs typeface="Aharoni" panose="02010803020104030203" pitchFamily="2" charset="-79"/>
-              </a:rPr>
-              <a:t> </a:t>
-            </a:r>
-            <a:r>
-              <a:rPr lang="de-DE" dirty="0" err="1">
-                <a:solidFill>
-                  <a:srgbClr val="FF0000"/>
-                </a:solidFill>
-                <a:latin typeface="Bahnschrift" panose="020B0502040204020203" pitchFamily="34" charset="0"/>
-                <a:cs typeface="Aharoni" panose="02010803020104030203" pitchFamily="2" charset="-79"/>
-              </a:rPr>
-              <a:t>to</a:t>
-            </a:r>
-            <a:r>
-              <a:rPr lang="de-DE" dirty="0">
-                <a:solidFill>
-                  <a:srgbClr val="FF0000"/>
-                </a:solidFill>
-                <a:latin typeface="Bahnschrift" panose="020B0502040204020203" pitchFamily="34" charset="0"/>
-                <a:cs typeface="Aharoni" panose="02010803020104030203" pitchFamily="2" charset="-79"/>
-              </a:rPr>
-              <a:t> </a:t>
-            </a:r>
-            <a:r>
-              <a:rPr lang="de-DE" dirty="0" err="1">
-                <a:solidFill>
-                  <a:srgbClr val="FF0000"/>
-                </a:solidFill>
-                <a:latin typeface="Bahnschrift" panose="020B0502040204020203" pitchFamily="34" charset="0"/>
-                <a:cs typeface="Aharoni" panose="02010803020104030203" pitchFamily="2" charset="-79"/>
-              </a:rPr>
-              <a:t>prison</a:t>
-            </a:r>
-            <a:r>
-              <a:rPr lang="de-DE" dirty="0">
-                <a:solidFill>
-                  <a:srgbClr val="FF0000"/>
-                </a:solidFill>
-                <a:latin typeface="Bahnschrift" panose="020B0502040204020203" pitchFamily="34" charset="0"/>
-                <a:cs typeface="Aharoni" panose="02010803020104030203" pitchFamily="2" charset="-79"/>
-              </a:rPr>
-              <a:t> </a:t>
-            </a:r>
-            <a:r>
-              <a:rPr lang="de-DE" dirty="0" err="1">
-                <a:solidFill>
-                  <a:srgbClr val="FF0000"/>
-                </a:solidFill>
-                <a:latin typeface="Bahnschrift" panose="020B0502040204020203" pitchFamily="34" charset="0"/>
-                <a:cs typeface="Aharoni" panose="02010803020104030203" pitchFamily="2" charset="-79"/>
-              </a:rPr>
-              <a:t>you</a:t>
-            </a:r>
-            <a:r>
-              <a:rPr lang="de-DE" dirty="0">
-                <a:solidFill>
-                  <a:srgbClr val="FF0000"/>
-                </a:solidFill>
-                <a:latin typeface="Bahnschrift" panose="020B0502040204020203" pitchFamily="34" charset="0"/>
-                <a:cs typeface="Aharoni" panose="02010803020104030203" pitchFamily="2" charset="-79"/>
-              </a:rPr>
-              <a:t> will not </a:t>
-            </a:r>
-            <a:r>
-              <a:rPr lang="de-DE" dirty="0" err="1">
-                <a:solidFill>
-                  <a:srgbClr val="FF0000"/>
-                </a:solidFill>
-                <a:latin typeface="Bahnschrift" panose="020B0502040204020203" pitchFamily="34" charset="0"/>
-                <a:cs typeface="Aharoni" panose="02010803020104030203" pitchFamily="2" charset="-79"/>
-              </a:rPr>
-              <a:t>receive</a:t>
-            </a:r>
-            <a:r>
-              <a:rPr lang="de-DE" dirty="0">
-                <a:solidFill>
-                  <a:srgbClr val="FF0000"/>
-                </a:solidFill>
-                <a:latin typeface="Bahnschrift" panose="020B0502040204020203" pitchFamily="34" charset="0"/>
-                <a:cs typeface="Aharoni" panose="02010803020104030203" pitchFamily="2" charset="-79"/>
-              </a:rPr>
-              <a:t> 200€$ </a:t>
-            </a:r>
-            <a:r>
-              <a:rPr lang="de-DE" dirty="0" err="1">
-                <a:solidFill>
-                  <a:srgbClr val="FF0000"/>
-                </a:solidFill>
-                <a:latin typeface="Bahnschrift" panose="020B0502040204020203" pitchFamily="34" charset="0"/>
-                <a:cs typeface="Aharoni" panose="02010803020104030203" pitchFamily="2" charset="-79"/>
-              </a:rPr>
-              <a:t>for</a:t>
-            </a:r>
-            <a:r>
-              <a:rPr lang="de-DE" dirty="0">
-                <a:solidFill>
-                  <a:srgbClr val="FF0000"/>
-                </a:solidFill>
-                <a:latin typeface="Bahnschrift" panose="020B0502040204020203" pitchFamily="34" charset="0"/>
-                <a:cs typeface="Aharoni" panose="02010803020104030203" pitchFamily="2" charset="-79"/>
-              </a:rPr>
-              <a:t> </a:t>
-            </a:r>
-            <a:r>
-              <a:rPr lang="de-DE" dirty="0" err="1">
-                <a:solidFill>
-                  <a:srgbClr val="FF0000"/>
-                </a:solidFill>
-                <a:latin typeface="Bahnschrift" panose="020B0502040204020203" pitchFamily="34" charset="0"/>
-                <a:cs typeface="Aharoni" panose="02010803020104030203" pitchFamily="2" charset="-79"/>
-              </a:rPr>
-              <a:t>moving</a:t>
-            </a:r>
-            <a:r>
-              <a:rPr lang="de-DE" dirty="0">
-                <a:solidFill>
-                  <a:srgbClr val="FF0000"/>
-                </a:solidFill>
-                <a:latin typeface="Bahnschrift" panose="020B0502040204020203" pitchFamily="34" charset="0"/>
-                <a:cs typeface="Aharoni" panose="02010803020104030203" pitchFamily="2" charset="-79"/>
-              </a:rPr>
-              <a:t> </a:t>
-            </a:r>
-            <a:r>
-              <a:rPr lang="de-DE" dirty="0" err="1">
-                <a:solidFill>
-                  <a:srgbClr val="FF0000"/>
-                </a:solidFill>
-                <a:latin typeface="Bahnschrift" panose="020B0502040204020203" pitchFamily="34" charset="0"/>
-                <a:cs typeface="Aharoni" panose="02010803020104030203" pitchFamily="2" charset="-79"/>
-              </a:rPr>
-              <a:t>over</a:t>
-            </a:r>
-            <a:r>
-              <a:rPr lang="de-DE" dirty="0">
-                <a:solidFill>
-                  <a:srgbClr val="FF0000"/>
-                </a:solidFill>
-                <a:latin typeface="Bahnschrift" panose="020B0502040204020203" pitchFamily="34" charset="0"/>
-                <a:cs typeface="Aharoni" panose="02010803020104030203" pitchFamily="2" charset="-79"/>
-              </a:rPr>
-              <a:t> GO.</a:t>
-            </a:r>
-          </a:p>
         </p:txBody>
       </p:sp>
     </p:spTree>
     <p:extLst>
       <p:ext uri="{BB962C8B-B14F-4D97-AF65-F5344CB8AC3E}">
-        <p14:creationId xmlns:p14="http://schemas.microsoft.com/office/powerpoint/2010/main" val="187431172"/>
+        <p14:creationId xmlns:p14="http://schemas.microsoft.com/office/powerpoint/2010/main" val="3623564745"/>
       </p:ext>
     </p:extLst>
   </p:cSld>
@@ -9638,8 +9518,8 @@
         </p:nvSpPr>
         <p:spPr>
           <a:xfrm>
-            <a:off x="2312751" y="2937751"/>
-            <a:ext cx="7566497" cy="1446550"/>
+            <a:off x="3532762" y="2869659"/>
+            <a:ext cx="5126476" cy="1508105"/>
           </a:xfrm>
           <a:prstGeom prst="rect">
             <a:avLst/>
@@ -9661,7 +9541,7 @@
                 <a:latin typeface="Bahnschrift" panose="020B0502040204020203" pitchFamily="34" charset="0"/>
                 <a:cs typeface="Aharoni" panose="02010803020104030203" pitchFamily="2" charset="-79"/>
               </a:rPr>
-              <a:t>You</a:t>
+              <a:t>You‘re</a:t>
             </a:r>
             <a:r>
               <a:rPr lang="de-DE" sz="2800" dirty="0">
@@ -9681,7 +9561,7 @@
                 <a:latin typeface="Bahnschrift" panose="020B0502040204020203" pitchFamily="34" charset="0"/>
                 <a:cs typeface="Aharoni" panose="02010803020104030203" pitchFamily="2" charset="-79"/>
               </a:rPr>
-              <a:t>were</a:t>
+              <a:t>busted</a:t>
             </a:r>
             <a:r>
               <a:rPr lang="de-DE" sz="2800" dirty="0">
@@ -9691,31 +9571,8 @@
                 <a:latin typeface="Bahnschrift" panose="020B0502040204020203" pitchFamily="34" charset="0"/>
                 <a:cs typeface="Aharoni" panose="02010803020104030203" pitchFamily="2" charset="-79"/>
               </a:rPr>
-              <a:t> </a:t>
-            </a:r>
-            <a:r>
-              <a:rPr lang="de-DE" sz="2800" dirty="0" err="1">
-                <a:solidFill>
-                  <a:srgbClr val="FF0000"/>
-                </a:solidFill>
-                <a:latin typeface="Bahnschrift" panose="020B0502040204020203" pitchFamily="34" charset="0"/>
-                <a:cs typeface="Aharoni" panose="02010803020104030203" pitchFamily="2" charset="-79"/>
-              </a:rPr>
-              <a:t>speeding</a:t>
-            </a:r>
-            <a:r>
-              <a:rPr lang="de-DE" sz="2800" dirty="0">
-                <a:solidFill>
-                  <a:srgbClr val="FF0000"/>
-                </a:solidFill>
-                <a:latin typeface="Bahnschrift" panose="020B0502040204020203" pitchFamily="34" charset="0"/>
-                <a:cs typeface="Aharoni" panose="02010803020104030203" pitchFamily="2" charset="-79"/>
-              </a:rPr>
               <a:t>!</a:t>
             </a:r>
-          </a:p>
-          <a:p>
-            <a:pPr algn="ctr"/>
             <a:endParaRPr lang="de-DE" sz="3600" dirty="0">
               <a:solidFill>
                 <a:srgbClr val="FF0000"/>
@@ -9726,15 +9583,205 @@
           </a:p>
           <a:p>
             <a:pPr algn="ctr"/>
-            <a:r>
-              <a:rPr lang="de-DE" sz="2400" dirty="0">
-                <a:solidFill>
-                  <a:srgbClr val="FF0000"/>
-                </a:solidFill>
-                <a:latin typeface="Bahnschrift" panose="020B0502040204020203" pitchFamily="34" charset="0"/>
-                <a:cs typeface="Aharoni" panose="02010803020104030203" pitchFamily="2" charset="-79"/>
-              </a:rPr>
-              <a:t>Pay 15€$</a:t>
+            <a:endParaRPr lang="de-DE" sz="2800" dirty="0">
+              <a:solidFill>
+                <a:srgbClr val="FF0000"/>
+              </a:solidFill>
+              <a:latin typeface="Bahnschrift" panose="020B0502040204020203" pitchFamily="34" charset="0"/>
+              <a:cs typeface="Aharoni" panose="02010803020104030203" pitchFamily="2" charset="-79"/>
+            </a:endParaRPr>
+          </a:p>
+          <a:p>
+            <a:pPr algn="ctr"/>
+            <a:r>
+              <a:rPr lang="de-DE" dirty="0">
+                <a:solidFill>
+                  <a:srgbClr val="FF0000"/>
+                </a:solidFill>
+                <a:latin typeface="Bahnschrift" panose="020B0502040204020203" pitchFamily="34" charset="0"/>
+                <a:cs typeface="Aharoni" panose="02010803020104030203" pitchFamily="2" charset="-79"/>
+              </a:rPr>
+              <a:t>On </a:t>
+            </a:r>
+            <a:r>
+              <a:rPr lang="de-DE" dirty="0" err="1">
+                <a:solidFill>
+                  <a:srgbClr val="FF0000"/>
+                </a:solidFill>
+                <a:latin typeface="Bahnschrift" panose="020B0502040204020203" pitchFamily="34" charset="0"/>
+                <a:cs typeface="Aharoni" panose="02010803020104030203" pitchFamily="2" charset="-79"/>
+              </a:rPr>
+              <a:t>your</a:t>
+            </a:r>
+            <a:r>
+              <a:rPr lang="de-DE" dirty="0">
+                <a:solidFill>
+                  <a:srgbClr val="FF0000"/>
+                </a:solidFill>
+                <a:latin typeface="Bahnschrift" panose="020B0502040204020203" pitchFamily="34" charset="0"/>
+                <a:cs typeface="Aharoni" panose="02010803020104030203" pitchFamily="2" charset="-79"/>
+              </a:rPr>
+              <a:t> </a:t>
+            </a:r>
+            <a:r>
+              <a:rPr lang="de-DE" dirty="0" err="1">
+                <a:solidFill>
+                  <a:srgbClr val="FF0000"/>
+                </a:solidFill>
+                <a:latin typeface="Bahnschrift" panose="020B0502040204020203" pitchFamily="34" charset="0"/>
+                <a:cs typeface="Aharoni" panose="02010803020104030203" pitchFamily="2" charset="-79"/>
+              </a:rPr>
+              <a:t>way</a:t>
+            </a:r>
+            <a:r>
+              <a:rPr lang="de-DE" dirty="0">
+                <a:solidFill>
+                  <a:srgbClr val="FF0000"/>
+                </a:solidFill>
+                <a:latin typeface="Bahnschrift" panose="020B0502040204020203" pitchFamily="34" charset="0"/>
+                <a:cs typeface="Aharoni" panose="02010803020104030203" pitchFamily="2" charset="-79"/>
+              </a:rPr>
+              <a:t> </a:t>
+            </a:r>
+            <a:r>
+              <a:rPr lang="de-DE" dirty="0" err="1">
+                <a:solidFill>
+                  <a:srgbClr val="FF0000"/>
+                </a:solidFill>
+                <a:latin typeface="Bahnschrift" panose="020B0502040204020203" pitchFamily="34" charset="0"/>
+                <a:cs typeface="Aharoni" panose="02010803020104030203" pitchFamily="2" charset="-79"/>
+              </a:rPr>
+              <a:t>to</a:t>
+            </a:r>
+            <a:r>
+              <a:rPr lang="de-DE" dirty="0">
+                <a:solidFill>
+                  <a:srgbClr val="FF0000"/>
+                </a:solidFill>
+                <a:latin typeface="Bahnschrift" panose="020B0502040204020203" pitchFamily="34" charset="0"/>
+                <a:cs typeface="Aharoni" panose="02010803020104030203" pitchFamily="2" charset="-79"/>
+              </a:rPr>
+              <a:t> </a:t>
+            </a:r>
+            <a:r>
+              <a:rPr lang="de-DE" dirty="0" err="1">
+                <a:solidFill>
+                  <a:srgbClr val="FF0000"/>
+                </a:solidFill>
+                <a:latin typeface="Bahnschrift" panose="020B0502040204020203" pitchFamily="34" charset="0"/>
+                <a:cs typeface="Aharoni" panose="02010803020104030203" pitchFamily="2" charset="-79"/>
+              </a:rPr>
+              <a:t>prison</a:t>
+            </a:r>
+            <a:r>
+              <a:rPr lang="de-DE" dirty="0">
+                <a:solidFill>
+                  <a:srgbClr val="FF0000"/>
+                </a:solidFill>
+                <a:latin typeface="Bahnschrift" panose="020B0502040204020203" pitchFamily="34" charset="0"/>
+                <a:cs typeface="Aharoni" panose="02010803020104030203" pitchFamily="2" charset="-79"/>
+              </a:rPr>
+              <a:t> </a:t>
+            </a:r>
+            <a:r>
+              <a:rPr lang="de-DE" dirty="0" err="1">
+                <a:solidFill>
+                  <a:srgbClr val="FF0000"/>
+                </a:solidFill>
+                <a:latin typeface="Bahnschrift" panose="020B0502040204020203" pitchFamily="34" charset="0"/>
+                <a:cs typeface="Aharoni" panose="02010803020104030203" pitchFamily="2" charset="-79"/>
+              </a:rPr>
+              <a:t>you</a:t>
+            </a:r>
+            <a:r>
+              <a:rPr lang="de-DE" dirty="0">
+                <a:solidFill>
+                  <a:srgbClr val="FF0000"/>
+                </a:solidFill>
+                <a:latin typeface="Bahnschrift" panose="020B0502040204020203" pitchFamily="34" charset="0"/>
+                <a:cs typeface="Aharoni" panose="02010803020104030203" pitchFamily="2" charset="-79"/>
+              </a:rPr>
+              <a:t> will not </a:t>
+            </a:r>
+            <a:r>
+              <a:rPr lang="de-DE" dirty="0" err="1">
+                <a:solidFill>
+                  <a:srgbClr val="FF0000"/>
+                </a:solidFill>
+                <a:latin typeface="Bahnschrift" panose="020B0502040204020203" pitchFamily="34" charset="0"/>
+                <a:cs typeface="Aharoni" panose="02010803020104030203" pitchFamily="2" charset="-79"/>
+              </a:rPr>
+              <a:t>receive</a:t>
+            </a:r>
+            <a:r>
+              <a:rPr lang="de-DE" dirty="0">
+                <a:solidFill>
+                  <a:srgbClr val="FF0000"/>
+                </a:solidFill>
+                <a:latin typeface="Bahnschrift" panose="020B0502040204020203" pitchFamily="34" charset="0"/>
+                <a:cs typeface="Aharoni" panose="02010803020104030203" pitchFamily="2" charset="-79"/>
+              </a:rPr>
+              <a:t> 200€$ </a:t>
+            </a:r>
+            <a:r>
+              <a:rPr lang="de-DE" dirty="0" err="1">
+                <a:solidFill>
+                  <a:srgbClr val="FF0000"/>
+                </a:solidFill>
+                <a:latin typeface="Bahnschrift" panose="020B0502040204020203" pitchFamily="34" charset="0"/>
+                <a:cs typeface="Aharoni" panose="02010803020104030203" pitchFamily="2" charset="-79"/>
+              </a:rPr>
+              <a:t>for</a:t>
+            </a:r>
+            <a:r>
+              <a:rPr lang="de-DE" dirty="0">
+                <a:solidFill>
+                  <a:srgbClr val="FF0000"/>
+                </a:solidFill>
+                <a:latin typeface="Bahnschrift" panose="020B0502040204020203" pitchFamily="34" charset="0"/>
+                <a:cs typeface="Aharoni" panose="02010803020104030203" pitchFamily="2" charset="-79"/>
+              </a:rPr>
+              <a:t> </a:t>
+            </a:r>
+            <a:r>
+              <a:rPr lang="de-DE" dirty="0" err="1">
+                <a:solidFill>
+                  <a:srgbClr val="FF0000"/>
+                </a:solidFill>
+                <a:latin typeface="Bahnschrift" panose="020B0502040204020203" pitchFamily="34" charset="0"/>
+                <a:cs typeface="Aharoni" panose="02010803020104030203" pitchFamily="2" charset="-79"/>
+              </a:rPr>
+              <a:t>moving</a:t>
+            </a:r>
+            <a:r>
+              <a:rPr lang="de-DE" dirty="0">
+                <a:solidFill>
+                  <a:srgbClr val="FF0000"/>
+                </a:solidFill>
+                <a:latin typeface="Bahnschrift" panose="020B0502040204020203" pitchFamily="34" charset="0"/>
+                <a:cs typeface="Aharoni" panose="02010803020104030203" pitchFamily="2" charset="-79"/>
+              </a:rPr>
+              <a:t> </a:t>
+            </a:r>
+            <a:r>
+              <a:rPr lang="de-DE" dirty="0" err="1">
+                <a:solidFill>
+                  <a:srgbClr val="FF0000"/>
+                </a:solidFill>
+                <a:latin typeface="Bahnschrift" panose="020B0502040204020203" pitchFamily="34" charset="0"/>
+                <a:cs typeface="Aharoni" panose="02010803020104030203" pitchFamily="2" charset="-79"/>
+              </a:rPr>
+              <a:t>over</a:t>
+            </a:r>
+            <a:r>
+              <a:rPr lang="de-DE" dirty="0">
+                <a:solidFill>
+                  <a:srgbClr val="FF0000"/>
+                </a:solidFill>
+                <a:latin typeface="Bahnschrift" panose="020B0502040204020203" pitchFamily="34" charset="0"/>
+                <a:cs typeface="Aharoni" panose="02010803020104030203" pitchFamily="2" charset="-79"/>
+              </a:rPr>
+              <a:t> GO.</a:t>
             </a:r>
           </a:p>
         </p:txBody>
@@ -9742,7 +9789,7 @@
     </p:spTree>
     <p:extLst>
       <p:ext uri="{BB962C8B-B14F-4D97-AF65-F5344CB8AC3E}">
-        <p14:creationId xmlns:p14="http://schemas.microsoft.com/office/powerpoint/2010/main" val="271054027"/>
+        <p14:creationId xmlns:p14="http://schemas.microsoft.com/office/powerpoint/2010/main" val="187431172"/>
       </p:ext>
     </p:extLst>
   </p:cSld>
@@ -9904,6 +9951,16 @@
           <a:p>
             <a:pPr algn="ctr"/>
             <a:r>
+              <a:rPr lang="de-DE" sz="2800" dirty="0" err="1">
+                <a:solidFill>
+                  <a:srgbClr val="FF0000"/>
+                </a:solidFill>
+                <a:latin typeface="Bahnschrift" panose="020B0502040204020203" pitchFamily="34" charset="0"/>
+                <a:cs typeface="Aharoni" panose="02010803020104030203" pitchFamily="2" charset="-79"/>
+              </a:rPr>
+              <a:t>You</a:t>
+            </a:r>
+            <a:r>
               <a:rPr lang="de-DE" sz="2800" dirty="0">
                 <a:solidFill>
                   <a:srgbClr val="FF0000"/>
@@ -9911,7 +9968,7 @@
                 <a:latin typeface="Bahnschrift" panose="020B0502040204020203" pitchFamily="34" charset="0"/>
                 <a:cs typeface="Aharoni" panose="02010803020104030203" pitchFamily="2" charset="-79"/>
               </a:rPr>
-              <a:t>The </a:t>
+              <a:t> </a:t>
             </a:r>
             <a:r>
               <a:rPr lang="de-DE" sz="2800" dirty="0" err="1">
@@ -9921,7 +9978,7 @@
                 <a:latin typeface="Bahnschrift" panose="020B0502040204020203" pitchFamily="34" charset="0"/>
                 <a:cs typeface="Aharoni" panose="02010803020104030203" pitchFamily="2" charset="-79"/>
               </a:rPr>
-              <a:t>bank</a:t>
+              <a:t>were</a:t>
             </a:r>
             <a:r>
               <a:rPr lang="de-DE" sz="2800" dirty="0">
@@ -9941,7 +9998,7 @@
                 <a:latin typeface="Bahnschrift" panose="020B0502040204020203" pitchFamily="34" charset="0"/>
                 <a:cs typeface="Aharoni" panose="02010803020104030203" pitchFamily="2" charset="-79"/>
               </a:rPr>
-              <a:t>pays</a:t>
+              <a:t>speeding</a:t>
             </a:r>
             <a:r>
               <a:rPr lang="de-DE" sz="2800" dirty="0">
@@ -9951,47 +10008,7 @@
                 <a:latin typeface="Bahnschrift" panose="020B0502040204020203" pitchFamily="34" charset="0"/>
                 <a:cs typeface="Aharoni" panose="02010803020104030203" pitchFamily="2" charset="-79"/>
               </a:rPr>
-              <a:t> </a:t>
-            </a:r>
-            <a:r>
-              <a:rPr lang="de-DE" sz="2800" dirty="0" err="1">
-                <a:solidFill>
-                  <a:srgbClr val="FF0000"/>
-                </a:solidFill>
-                <a:latin typeface="Bahnschrift" panose="020B0502040204020203" pitchFamily="34" charset="0"/>
-                <a:cs typeface="Aharoni" panose="02010803020104030203" pitchFamily="2" charset="-79"/>
-              </a:rPr>
-              <a:t>you</a:t>
-            </a:r>
-            <a:r>
-              <a:rPr lang="de-DE" sz="2800" dirty="0">
-                <a:solidFill>
-                  <a:srgbClr val="FF0000"/>
-                </a:solidFill>
-                <a:latin typeface="Bahnschrift" panose="020B0502040204020203" pitchFamily="34" charset="0"/>
-                <a:cs typeface="Aharoni" panose="02010803020104030203" pitchFamily="2" charset="-79"/>
-              </a:rPr>
-              <a:t> </a:t>
-            </a:r>
-            <a:r>
-              <a:rPr lang="de-DE" sz="2800" dirty="0" err="1">
-                <a:solidFill>
-                  <a:srgbClr val="FF0000"/>
-                </a:solidFill>
-                <a:latin typeface="Bahnschrift" panose="020B0502040204020203" pitchFamily="34" charset="0"/>
-                <a:cs typeface="Aharoni" panose="02010803020104030203" pitchFamily="2" charset="-79"/>
-              </a:rPr>
-              <a:t>dividend</a:t>
-            </a:r>
-            <a:r>
-              <a:rPr lang="de-DE" sz="2800" dirty="0">
-                <a:solidFill>
-                  <a:srgbClr val="FF0000"/>
-                </a:solidFill>
-                <a:latin typeface="Bahnschrift" panose="020B0502040204020203" pitchFamily="34" charset="0"/>
-                <a:cs typeface="Aharoni" panose="02010803020104030203" pitchFamily="2" charset="-79"/>
-              </a:rPr>
-              <a:t>.</a:t>
+              <a:t>!</a:t>
             </a:r>
           </a:p>
           <a:p>
@@ -10007,16 +10024,6 @@
           <a:p>
             <a:pPr algn="ctr"/>
             <a:r>
-              <a:rPr lang="de-DE" sz="2400" dirty="0" err="1">
-                <a:solidFill>
-                  <a:srgbClr val="FF0000"/>
-                </a:solidFill>
-                <a:latin typeface="Bahnschrift" panose="020B0502040204020203" pitchFamily="34" charset="0"/>
-                <a:cs typeface="Aharoni" panose="02010803020104030203" pitchFamily="2" charset="-79"/>
-              </a:rPr>
-              <a:t>You</a:t>
-            </a:r>
-            <a:r>
               <a:rPr lang="de-DE" sz="2400" dirty="0">
                 <a:solidFill>
                   <a:srgbClr val="FF0000"/>
@@ -10024,27 +10031,7 @@
                 <a:latin typeface="Bahnschrift" panose="020B0502040204020203" pitchFamily="34" charset="0"/>
                 <a:cs typeface="Aharoni" panose="02010803020104030203" pitchFamily="2" charset="-79"/>
               </a:rPr>
-              <a:t> </a:t>
-            </a:r>
-            <a:r>
-              <a:rPr lang="de-DE" sz="2400" dirty="0" err="1">
-                <a:solidFill>
-                  <a:srgbClr val="FF0000"/>
-                </a:solidFill>
-                <a:latin typeface="Bahnschrift" panose="020B0502040204020203" pitchFamily="34" charset="0"/>
-                <a:cs typeface="Aharoni" panose="02010803020104030203" pitchFamily="2" charset="-79"/>
-              </a:rPr>
-              <a:t>receive</a:t>
-            </a:r>
-            <a:r>
-              <a:rPr lang="de-DE" sz="2400" dirty="0">
-                <a:solidFill>
-                  <a:srgbClr val="FF0000"/>
-                </a:solidFill>
-                <a:latin typeface="Bahnschrift" panose="020B0502040204020203" pitchFamily="34" charset="0"/>
-                <a:cs typeface="Aharoni" panose="02010803020104030203" pitchFamily="2" charset="-79"/>
-              </a:rPr>
-              <a:t> 50€$</a:t>
+              <a:t>Pay 15€$</a:t>
             </a:r>
           </a:p>
         </p:txBody>
@@ -10052,7 +10039,7 @@
     </p:spTree>
     <p:extLst>
       <p:ext uri="{BB962C8B-B14F-4D97-AF65-F5344CB8AC3E}">
-        <p14:creationId xmlns:p14="http://schemas.microsoft.com/office/powerpoint/2010/main" val="1757737279"/>
+        <p14:creationId xmlns:p14="http://schemas.microsoft.com/office/powerpoint/2010/main" val="271054027"/>
       </p:ext>
     </p:extLst>
   </p:cSld>
@@ -10221,7 +10208,7 @@
                 <a:latin typeface="Bahnschrift" panose="020B0502040204020203" pitchFamily="34" charset="0"/>
                 <a:cs typeface="Aharoni" panose="02010803020104030203" pitchFamily="2" charset="-79"/>
               </a:rPr>
-              <a:t>Move </a:t>
+              <a:t>The </a:t>
             </a:r>
             <a:r>
               <a:rPr lang="de-DE" sz="2800" dirty="0" err="1">
@@ -10231,7 +10218,7 @@
                 <a:latin typeface="Bahnschrift" panose="020B0502040204020203" pitchFamily="34" charset="0"/>
                 <a:cs typeface="Aharoni" panose="02010803020104030203" pitchFamily="2" charset="-79"/>
               </a:rPr>
-              <a:t>forward</a:t>
+              <a:t>bank</a:t>
             </a:r>
             <a:r>
               <a:rPr lang="de-DE" sz="2800" dirty="0">
@@ -10251,7 +10238,7 @@
                 <a:latin typeface="Bahnschrift" panose="020B0502040204020203" pitchFamily="34" charset="0"/>
                 <a:cs typeface="Aharoni" panose="02010803020104030203" pitchFamily="2" charset="-79"/>
               </a:rPr>
-              <a:t>until</a:t>
+              <a:t>pays</a:t>
             </a:r>
             <a:r>
               <a:rPr lang="de-DE" sz="2800" dirty="0">
@@ -10271,7 +10258,7 @@
                 <a:latin typeface="Bahnschrift" panose="020B0502040204020203" pitchFamily="34" charset="0"/>
                 <a:cs typeface="Aharoni" panose="02010803020104030203" pitchFamily="2" charset="-79"/>
               </a:rPr>
-              <a:t>the</a:t>
+              <a:t>you</a:t>
             </a:r>
             <a:r>
               <a:rPr lang="de-DE" sz="2800" dirty="0">
@@ -10284,22 +10271,25 @@
               <a:t> </a:t>
             </a:r>
             <a:r>
-              <a:rPr lang="de-DE" sz="2800" i="1" dirty="0">
-                <a:solidFill>
-                  <a:srgbClr val="FF0000"/>
-                </a:solidFill>
-                <a:latin typeface="Bahnschrift" panose="020B0502040204020203" pitchFamily="34" charset="0"/>
-                <a:cs typeface="Aharoni" panose="02010803020104030203" pitchFamily="2" charset="-79"/>
-              </a:rPr>
-              <a:t>Seestraße.</a:t>
-            </a:r>
-            <a:endParaRPr lang="de-DE" sz="2800" dirty="0">
-              <a:solidFill>
-                <a:srgbClr val="FF0000"/>
-              </a:solidFill>
-              <a:latin typeface="Bahnschrift" panose="020B0502040204020203" pitchFamily="34" charset="0"/>
-              <a:cs typeface="Aharoni" panose="02010803020104030203" pitchFamily="2" charset="-79"/>
-            </a:endParaRPr>
+              <a:rPr lang="de-DE" sz="2800" dirty="0" err="1">
+                <a:solidFill>
+                  <a:srgbClr val="FF0000"/>
+                </a:solidFill>
+                <a:latin typeface="Bahnschrift" panose="020B0502040204020203" pitchFamily="34" charset="0"/>
+                <a:cs typeface="Aharoni" panose="02010803020104030203" pitchFamily="2" charset="-79"/>
+              </a:rPr>
+              <a:t>dividend</a:t>
+            </a:r>
+            <a:r>
+              <a:rPr lang="de-DE" sz="2800" dirty="0">
+                <a:solidFill>
+                  <a:srgbClr val="FF0000"/>
+                </a:solidFill>
+                <a:latin typeface="Bahnschrift" panose="020B0502040204020203" pitchFamily="34" charset="0"/>
+                <a:cs typeface="Aharoni" panose="02010803020104030203" pitchFamily="2" charset="-79"/>
+              </a:rPr>
+              <a:t>.</a:t>
+            </a:r>
           </a:p>
           <a:p>
             <a:pPr algn="ctr"/>
@@ -10321,7 +10311,7 @@
                 <a:latin typeface="Bahnschrift" panose="020B0502040204020203" pitchFamily="34" charset="0"/>
                 <a:cs typeface="Aharoni" panose="02010803020104030203" pitchFamily="2" charset="-79"/>
               </a:rPr>
-              <a:t>When</a:t>
+              <a:t>You</a:t>
             </a:r>
             <a:r>
               <a:rPr lang="de-DE" sz="2400" dirty="0">
@@ -10341,7 +10331,7 @@
                 <a:latin typeface="Bahnschrift" panose="020B0502040204020203" pitchFamily="34" charset="0"/>
                 <a:cs typeface="Aharoni" panose="02010803020104030203" pitchFamily="2" charset="-79"/>
               </a:rPr>
-              <a:t>passing</a:t>
+              <a:t>receive</a:t>
             </a:r>
             <a:r>
               <a:rPr lang="de-DE" sz="2400" dirty="0">
@@ -10351,47 +10341,7 @@
                 <a:latin typeface="Bahnschrift" panose="020B0502040204020203" pitchFamily="34" charset="0"/>
                 <a:cs typeface="Aharoni" panose="02010803020104030203" pitchFamily="2" charset="-79"/>
               </a:rPr>
-              <a:t> GO </a:t>
-            </a:r>
-            <a:r>
-              <a:rPr lang="de-DE" sz="2400" dirty="0" err="1">
-                <a:solidFill>
-                  <a:srgbClr val="FF0000"/>
-                </a:solidFill>
-                <a:latin typeface="Bahnschrift" panose="020B0502040204020203" pitchFamily="34" charset="0"/>
-                <a:cs typeface="Aharoni" panose="02010803020104030203" pitchFamily="2" charset="-79"/>
-              </a:rPr>
-              <a:t>you</a:t>
-            </a:r>
-            <a:r>
-              <a:rPr lang="de-DE" sz="2400" dirty="0">
-                <a:solidFill>
-                  <a:srgbClr val="FF0000"/>
-                </a:solidFill>
-                <a:latin typeface="Bahnschrift" panose="020B0502040204020203" pitchFamily="34" charset="0"/>
-                <a:cs typeface="Aharoni" panose="02010803020104030203" pitchFamily="2" charset="-79"/>
-              </a:rPr>
-              <a:t> will </a:t>
-            </a:r>
-            <a:r>
-              <a:rPr lang="de-DE" sz="2400" dirty="0" err="1">
-                <a:solidFill>
-                  <a:srgbClr val="FF0000"/>
-                </a:solidFill>
-                <a:latin typeface="Bahnschrift" panose="020B0502040204020203" pitchFamily="34" charset="0"/>
-                <a:cs typeface="Aharoni" panose="02010803020104030203" pitchFamily="2" charset="-79"/>
-              </a:rPr>
-              <a:t>receive</a:t>
-            </a:r>
-            <a:r>
-              <a:rPr lang="de-DE" sz="2400" dirty="0">
-                <a:solidFill>
-                  <a:srgbClr val="FF0000"/>
-                </a:solidFill>
-                <a:latin typeface="Bahnschrift" panose="020B0502040204020203" pitchFamily="34" charset="0"/>
-                <a:cs typeface="Aharoni" panose="02010803020104030203" pitchFamily="2" charset="-79"/>
-              </a:rPr>
-              <a:t> 200€$</a:t>
+              <a:t> 50€$</a:t>
             </a:r>
           </a:p>
         </p:txBody>
@@ -10399,7 +10349,7 @@
     </p:spTree>
     <p:extLst>
       <p:ext uri="{BB962C8B-B14F-4D97-AF65-F5344CB8AC3E}">
-        <p14:creationId xmlns:p14="http://schemas.microsoft.com/office/powerpoint/2010/main" val="1616534667"/>
+        <p14:creationId xmlns:p14="http://schemas.microsoft.com/office/powerpoint/2010/main" val="1757737279"/>
       </p:ext>
     </p:extLst>
   </p:cSld>
@@ -10928,7 +10878,7 @@
                 <a:latin typeface="Bahnschrift" panose="020B0502040204020203" pitchFamily="34" charset="0"/>
                 <a:cs typeface="Aharoni" panose="02010803020104030203" pitchFamily="2" charset="-79"/>
               </a:rPr>
-              <a:t>Südbahnhof.</a:t>
+              <a:t>Seestraße.</a:t>
             </a:r>
             <a:endParaRPr lang="de-DE" sz="2800" dirty="0">
               <a:solidFill>
@@ -11036,7 +10986,7 @@
     </p:spTree>
     <p:extLst>
       <p:ext uri="{BB962C8B-B14F-4D97-AF65-F5344CB8AC3E}">
-        <p14:creationId xmlns:p14="http://schemas.microsoft.com/office/powerpoint/2010/main" val="25313529"/>
+        <p14:creationId xmlns:p14="http://schemas.microsoft.com/office/powerpoint/2010/main" val="1616534667"/>
       </p:ext>
     </p:extLst>
   </p:cSld>
@@ -11183,6 +11133,353 @@
         <p:spPr>
           <a:xfrm>
             <a:off x="2312751" y="2937751"/>
+            <a:ext cx="7566497" cy="1446550"/>
+          </a:xfrm>
+          <a:prstGeom prst="rect">
+            <a:avLst/>
+          </a:prstGeom>
+          <a:noFill/>
+        </p:spPr>
+        <p:txBody>
+          <a:bodyPr wrap="square" rtlCol="0">
+            <a:spAutoFit/>
+          </a:bodyPr>
+          <a:lstStyle/>
+          <a:p>
+            <a:pPr algn="ctr"/>
+            <a:r>
+              <a:rPr lang="de-DE" sz="2800" dirty="0">
+                <a:solidFill>
+                  <a:srgbClr val="FF0000"/>
+                </a:solidFill>
+                <a:latin typeface="Bahnschrift" panose="020B0502040204020203" pitchFamily="34" charset="0"/>
+                <a:cs typeface="Aharoni" panose="02010803020104030203" pitchFamily="2" charset="-79"/>
+              </a:rPr>
+              <a:t>Move </a:t>
+            </a:r>
+            <a:r>
+              <a:rPr lang="de-DE" sz="2800" dirty="0" err="1">
+                <a:solidFill>
+                  <a:srgbClr val="FF0000"/>
+                </a:solidFill>
+                <a:latin typeface="Bahnschrift" panose="020B0502040204020203" pitchFamily="34" charset="0"/>
+                <a:cs typeface="Aharoni" panose="02010803020104030203" pitchFamily="2" charset="-79"/>
+              </a:rPr>
+              <a:t>forward</a:t>
+            </a:r>
+            <a:r>
+              <a:rPr lang="de-DE" sz="2800" dirty="0">
+                <a:solidFill>
+                  <a:srgbClr val="FF0000"/>
+                </a:solidFill>
+                <a:latin typeface="Bahnschrift" panose="020B0502040204020203" pitchFamily="34" charset="0"/>
+                <a:cs typeface="Aharoni" panose="02010803020104030203" pitchFamily="2" charset="-79"/>
+              </a:rPr>
+              <a:t> </a:t>
+            </a:r>
+            <a:r>
+              <a:rPr lang="de-DE" sz="2800" dirty="0" err="1">
+                <a:solidFill>
+                  <a:srgbClr val="FF0000"/>
+                </a:solidFill>
+                <a:latin typeface="Bahnschrift" panose="020B0502040204020203" pitchFamily="34" charset="0"/>
+                <a:cs typeface="Aharoni" panose="02010803020104030203" pitchFamily="2" charset="-79"/>
+              </a:rPr>
+              <a:t>until</a:t>
+            </a:r>
+            <a:r>
+              <a:rPr lang="de-DE" sz="2800" dirty="0">
+                <a:solidFill>
+                  <a:srgbClr val="FF0000"/>
+                </a:solidFill>
+                <a:latin typeface="Bahnschrift" panose="020B0502040204020203" pitchFamily="34" charset="0"/>
+                <a:cs typeface="Aharoni" panose="02010803020104030203" pitchFamily="2" charset="-79"/>
+              </a:rPr>
+              <a:t> </a:t>
+            </a:r>
+            <a:r>
+              <a:rPr lang="de-DE" sz="2800" dirty="0" err="1">
+                <a:solidFill>
+                  <a:srgbClr val="FF0000"/>
+                </a:solidFill>
+                <a:latin typeface="Bahnschrift" panose="020B0502040204020203" pitchFamily="34" charset="0"/>
+                <a:cs typeface="Aharoni" panose="02010803020104030203" pitchFamily="2" charset="-79"/>
+              </a:rPr>
+              <a:t>the</a:t>
+            </a:r>
+            <a:r>
+              <a:rPr lang="de-DE" sz="2800" dirty="0">
+                <a:solidFill>
+                  <a:srgbClr val="FF0000"/>
+                </a:solidFill>
+                <a:latin typeface="Bahnschrift" panose="020B0502040204020203" pitchFamily="34" charset="0"/>
+                <a:cs typeface="Aharoni" panose="02010803020104030203" pitchFamily="2" charset="-79"/>
+              </a:rPr>
+              <a:t> </a:t>
+            </a:r>
+            <a:r>
+              <a:rPr lang="de-DE" sz="2800" i="1" dirty="0">
+                <a:solidFill>
+                  <a:srgbClr val="FF0000"/>
+                </a:solidFill>
+                <a:latin typeface="Bahnschrift" panose="020B0502040204020203" pitchFamily="34" charset="0"/>
+                <a:cs typeface="Aharoni" panose="02010803020104030203" pitchFamily="2" charset="-79"/>
+              </a:rPr>
+              <a:t>Südbahnhof.</a:t>
+            </a:r>
+            <a:endParaRPr lang="de-DE" sz="2800" dirty="0">
+              <a:solidFill>
+                <a:srgbClr val="FF0000"/>
+              </a:solidFill>
+              <a:latin typeface="Bahnschrift" panose="020B0502040204020203" pitchFamily="34" charset="0"/>
+              <a:cs typeface="Aharoni" panose="02010803020104030203" pitchFamily="2" charset="-79"/>
+            </a:endParaRPr>
+          </a:p>
+          <a:p>
+            <a:pPr algn="ctr"/>
+            <a:endParaRPr lang="de-DE" sz="3600" dirty="0">
+              <a:solidFill>
+                <a:srgbClr val="FF0000"/>
+              </a:solidFill>
+              <a:latin typeface="Bahnschrift" panose="020B0502040204020203" pitchFamily="34" charset="0"/>
+              <a:cs typeface="Aharoni" panose="02010803020104030203" pitchFamily="2" charset="-79"/>
+            </a:endParaRPr>
+          </a:p>
+          <a:p>
+            <a:pPr algn="ctr"/>
+            <a:r>
+              <a:rPr lang="de-DE" sz="2400" dirty="0" err="1">
+                <a:solidFill>
+                  <a:srgbClr val="FF0000"/>
+                </a:solidFill>
+                <a:latin typeface="Bahnschrift" panose="020B0502040204020203" pitchFamily="34" charset="0"/>
+                <a:cs typeface="Aharoni" panose="02010803020104030203" pitchFamily="2" charset="-79"/>
+              </a:rPr>
+              <a:t>When</a:t>
+            </a:r>
+            <a:r>
+              <a:rPr lang="de-DE" sz="2400" dirty="0">
+                <a:solidFill>
+                  <a:srgbClr val="FF0000"/>
+                </a:solidFill>
+                <a:latin typeface="Bahnschrift" panose="020B0502040204020203" pitchFamily="34" charset="0"/>
+                <a:cs typeface="Aharoni" panose="02010803020104030203" pitchFamily="2" charset="-79"/>
+              </a:rPr>
+              <a:t> </a:t>
+            </a:r>
+            <a:r>
+              <a:rPr lang="de-DE" sz="2400" dirty="0" err="1">
+                <a:solidFill>
+                  <a:srgbClr val="FF0000"/>
+                </a:solidFill>
+                <a:latin typeface="Bahnschrift" panose="020B0502040204020203" pitchFamily="34" charset="0"/>
+                <a:cs typeface="Aharoni" panose="02010803020104030203" pitchFamily="2" charset="-79"/>
+              </a:rPr>
+              <a:t>passing</a:t>
+            </a:r>
+            <a:r>
+              <a:rPr lang="de-DE" sz="2400" dirty="0">
+                <a:solidFill>
+                  <a:srgbClr val="FF0000"/>
+                </a:solidFill>
+                <a:latin typeface="Bahnschrift" panose="020B0502040204020203" pitchFamily="34" charset="0"/>
+                <a:cs typeface="Aharoni" panose="02010803020104030203" pitchFamily="2" charset="-79"/>
+              </a:rPr>
+              <a:t> GO </a:t>
+            </a:r>
+            <a:r>
+              <a:rPr lang="de-DE" sz="2400" dirty="0" err="1">
+                <a:solidFill>
+                  <a:srgbClr val="FF0000"/>
+                </a:solidFill>
+                <a:latin typeface="Bahnschrift" panose="020B0502040204020203" pitchFamily="34" charset="0"/>
+                <a:cs typeface="Aharoni" panose="02010803020104030203" pitchFamily="2" charset="-79"/>
+              </a:rPr>
+              <a:t>you</a:t>
+            </a:r>
+            <a:r>
+              <a:rPr lang="de-DE" sz="2400" dirty="0">
+                <a:solidFill>
+                  <a:srgbClr val="FF0000"/>
+                </a:solidFill>
+                <a:latin typeface="Bahnschrift" panose="020B0502040204020203" pitchFamily="34" charset="0"/>
+                <a:cs typeface="Aharoni" panose="02010803020104030203" pitchFamily="2" charset="-79"/>
+              </a:rPr>
+              <a:t> will </a:t>
+            </a:r>
+            <a:r>
+              <a:rPr lang="de-DE" sz="2400" dirty="0" err="1">
+                <a:solidFill>
+                  <a:srgbClr val="FF0000"/>
+                </a:solidFill>
+                <a:latin typeface="Bahnschrift" panose="020B0502040204020203" pitchFamily="34" charset="0"/>
+                <a:cs typeface="Aharoni" panose="02010803020104030203" pitchFamily="2" charset="-79"/>
+              </a:rPr>
+              <a:t>receive</a:t>
+            </a:r>
+            <a:r>
+              <a:rPr lang="de-DE" sz="2400" dirty="0">
+                <a:solidFill>
+                  <a:srgbClr val="FF0000"/>
+                </a:solidFill>
+                <a:latin typeface="Bahnschrift" panose="020B0502040204020203" pitchFamily="34" charset="0"/>
+                <a:cs typeface="Aharoni" panose="02010803020104030203" pitchFamily="2" charset="-79"/>
+              </a:rPr>
+              <a:t> 200€$</a:t>
+            </a:r>
+          </a:p>
+        </p:txBody>
+      </p:sp>
+    </p:spTree>
+    <p:extLst>
+      <p:ext uri="{BB962C8B-B14F-4D97-AF65-F5344CB8AC3E}">
+        <p14:creationId xmlns:p14="http://schemas.microsoft.com/office/powerpoint/2010/main" val="25313529"/>
+      </p:ext>
+    </p:extLst>
+  </p:cSld>
+  <p:clrMapOvr>
+    <a:masterClrMapping/>
+  </p:clrMapOvr>
+</p:sld>
+</file>
+
+<file path=ppt/slides/slide32.xml><?xml version="1.0" encoding="utf-8"?>
+<p:sld xmlns:a="http://schemas.openxmlformats.org/drawingml/2006/main" xmlns:r="http://schemas.openxmlformats.org/officeDocument/2006/relationships" xmlns:p="http://schemas.openxmlformats.org/presentationml/2006/main">
+  <p:cSld>
+    <p:spTree>
+      <p:nvGrpSpPr>
+        <p:cNvPr id="1" name=""/>
+        <p:cNvGrpSpPr/>
+        <p:nvPr/>
+      </p:nvGrpSpPr>
+      <p:grpSpPr>
+        <a:xfrm>
+          <a:off x="0" y="0"/>
+          <a:ext cx="0" cy="0"/>
+          <a:chOff x="0" y="0"/>
+          <a:chExt cx="0" cy="0"/>
+        </a:xfrm>
+      </p:grpSpPr>
+      <p:sp>
+        <p:nvSpPr>
+          <p:cNvPr id="4" name="Rechteck 3">
+            <a:extLst>
+              <a:ext uri="{FF2B5EF4-FFF2-40B4-BE49-F238E27FC236}">
+                <a16:creationId xmlns:a16="http://schemas.microsoft.com/office/drawing/2014/main" id="{8FC8D0D7-EB7B-88E4-C192-5861C72371FF}"/>
+              </a:ext>
+            </a:extLst>
+          </p:cNvPr>
+          <p:cNvSpPr/>
+          <p:nvPr/>
+        </p:nvSpPr>
+        <p:spPr>
+          <a:xfrm>
+            <a:off x="155644" y="145916"/>
+            <a:ext cx="11887200" cy="6566170"/>
+          </a:xfrm>
+          <a:prstGeom prst="rect">
+            <a:avLst/>
+          </a:prstGeom>
+          <a:noFill/>
+          <a:ln w="57150">
+            <a:solidFill>
+              <a:srgbClr val="FF0000"/>
+            </a:solidFill>
+          </a:ln>
+        </p:spPr>
+        <p:style>
+          <a:lnRef idx="2">
+            <a:schemeClr val="accent1">
+              <a:shade val="50000"/>
+            </a:schemeClr>
+          </a:lnRef>
+          <a:fillRef idx="1">
+            <a:schemeClr val="accent1"/>
+          </a:fillRef>
+          <a:effectRef idx="0">
+            <a:schemeClr val="accent1"/>
+          </a:effectRef>
+          <a:fontRef idx="minor">
+            <a:schemeClr val="lt1"/>
+          </a:fontRef>
+        </p:style>
+        <p:txBody>
+          <a:bodyPr rtlCol="0" anchor="ctr"/>
+          <a:lstStyle/>
+          <a:p>
+            <a:pPr algn="ctr"/>
+            <a:endParaRPr lang="de-DE">
+              <a:solidFill>
+                <a:srgbClr val="FF0000"/>
+              </a:solidFill>
+            </a:endParaRPr>
+          </a:p>
+        </p:txBody>
+      </p:sp>
+      <p:sp>
+        <p:nvSpPr>
+          <p:cNvPr id="5" name="Textfeld 4">
+            <a:extLst>
+              <a:ext uri="{FF2B5EF4-FFF2-40B4-BE49-F238E27FC236}">
+                <a16:creationId xmlns:a16="http://schemas.microsoft.com/office/drawing/2014/main" id="{BDBA4B2F-CFF6-57D4-32F9-72A85833E495}"/>
+              </a:ext>
+            </a:extLst>
+          </p:cNvPr>
+          <p:cNvSpPr txBox="1"/>
+          <p:nvPr/>
+        </p:nvSpPr>
+        <p:spPr>
+          <a:xfrm>
+            <a:off x="2919919" y="1391055"/>
+            <a:ext cx="6352162" cy="707886"/>
+          </a:xfrm>
+          <a:prstGeom prst="rect">
+            <a:avLst/>
+          </a:prstGeom>
+          <a:noFill/>
+        </p:spPr>
+        <p:txBody>
+          <a:bodyPr wrap="square" rtlCol="0">
+            <a:spAutoFit/>
+          </a:bodyPr>
+          <a:lstStyle/>
+          <a:p>
+            <a:pPr algn="ctr"/>
+            <a:r>
+              <a:rPr lang="de-DE" sz="4000" dirty="0">
+                <a:solidFill>
+                  <a:srgbClr val="FF0000"/>
+                </a:solidFill>
+                <a:latin typeface="Bahnschrift" panose="020B0502040204020203" pitchFamily="34" charset="0"/>
+                <a:cs typeface="Aharoni" panose="02010803020104030203" pitchFamily="2" charset="-79"/>
+              </a:rPr>
+              <a:t>Event Card</a:t>
+            </a:r>
+            <a:endParaRPr lang="de-DE" sz="3200" dirty="0">
+              <a:solidFill>
+                <a:srgbClr val="FF0000"/>
+              </a:solidFill>
+              <a:latin typeface="Bahnschrift" panose="020B0502040204020203" pitchFamily="34" charset="0"/>
+              <a:cs typeface="Aharoni" panose="02010803020104030203" pitchFamily="2" charset="-79"/>
+            </a:endParaRPr>
+          </a:p>
+        </p:txBody>
+      </p:sp>
+      <p:sp>
+        <p:nvSpPr>
+          <p:cNvPr id="6" name="Textfeld 5">
+            <a:extLst>
+              <a:ext uri="{FF2B5EF4-FFF2-40B4-BE49-F238E27FC236}">
+                <a16:creationId xmlns:a16="http://schemas.microsoft.com/office/drawing/2014/main" id="{27FA8842-D2B4-7795-E46C-4CEB0DB0EF46}"/>
+              </a:ext>
+            </a:extLst>
+          </p:cNvPr>
+          <p:cNvSpPr txBox="1"/>
+          <p:nvPr/>
+        </p:nvSpPr>
+        <p:spPr>
+          <a:xfrm>
+            <a:off x="2312751" y="2937751"/>
             <a:ext cx="7566497" cy="2246769"/>
           </a:xfrm>
           <a:prstGeom prst="rect">
@@ -11523,7 +11820,7 @@
 </p:sld>
 </file>
 
-<file path=ppt/slides/slide32.xml><?xml version="1.0" encoding="utf-8"?>
+<file path=ppt/slides/slide33.xml><?xml version="1.0" encoding="utf-8"?>
 <p:sld xmlns:a="http://schemas.openxmlformats.org/drawingml/2006/main" xmlns:r="http://schemas.openxmlformats.org/officeDocument/2006/relationships" xmlns:p="http://schemas.openxmlformats.org/presentationml/2006/main">
   <p:cSld>
     <p:spTree>

</xml_diff>